<commit_message>
docs: DB schema-sync (personal/final, click-pull) model + arch/AI in deck
- DESIGN.md 핵심기능 3 reworked: 개인 vs 최종 스키마, 변경점 감지, 클릭
  적용(pull, git model), 추가=안전 / 삭제·타입변경=확인, Liquibase/Flyway
  활용 권장. New figure design-fig4 (pull model).
- New design-arch figure (React→FastAPI→AI/Oracle with env under each box).
- Rebuild progress deck: architecture image + env, AI as 2 options
  (Qwen3-8B vs 사내 playground, comparison), docx+ambiguity as one process,
  richer feature detail, DB pull model slide.
</commit_message>
<xml_diff>
--- a/docs/진행공유_요구사항자동화.pptx
+++ b/docs/진행공유_요구사항자동화.pptx
@@ -15,9 +15,10 @@
     <p:sldId id="263" r:id="rId9"/>
     <p:sldId id="264" r:id="rId10"/>
     <p:sldId id="265" r:id="rId11"/>
+    <p:sldId id="266" r:id="rId12"/>
   </p:sldIdLst>
   <p:notesMasterIdLst>
-    <p:notesMasterId r:id="rId12"/>
+    <p:notesMasterId r:id="rId13"/>
   </p:notesMasterIdLst>
   <p:sldSz cx="12191695" cy="6858000"/>
   <p:notesSz cx="6858000" cy="12191695"/>
@@ -623,6 +624,94 @@
             <a:fld id="{F7021451-1387-4CA6-816F-3879F97B5CBC}" type="slidenum">
               <a:rPr lang="en-US"/>
               <a:t>10</a:t>
+            </a:fld>
+            <a:endParaRPr lang="en-US"/>
+          </a:p>
+        </p:txBody>
+      </p:sp>
+    </p:spTree>
+    <p:extLst>
+      <p:ext uri="{BB962C8B-B14F-4D97-AF65-F5344CB8AC3E}">
+        <p14:creationId xmlns:p14="http://schemas.microsoft.com/office/powerpoint/2010/main" val="1024086991"/>
+      </p:ext>
+    </p:extLst>
+  </p:cSld>
+  <p:clrMapOvr>
+    <a:masterClrMapping/>
+  </p:clrMapOvr>
+</p:notes>
+</file>
+
+<file path=ppt/notesSlides/notesSlide11.xml><?xml version="1.0" encoding="utf-8"?>
+<p:notes xmlns:a="http://schemas.openxmlformats.org/drawingml/2006/main" xmlns:r="http://schemas.openxmlformats.org/officeDocument/2006/relationships" xmlns:p="http://schemas.openxmlformats.org/presentationml/2006/main">
+  <p:cSld>
+    <p:spTree>
+      <p:nvGrpSpPr>
+        <p:cNvPr id="1" name=""/>
+        <p:cNvGrpSpPr/>
+        <p:nvPr/>
+      </p:nvGrpSpPr>
+      <p:grpSpPr>
+        <a:xfrm>
+          <a:off x="0" y="0"/>
+          <a:ext cx="0" cy="0"/>
+          <a:chOff x="0" y="0"/>
+          <a:chExt cx="0" cy="0"/>
+        </a:xfrm>
+      </p:grpSpPr>
+      <p:sp>
+        <p:nvSpPr>
+          <p:cNvPr id="2" name="Slide Image Placeholder 1"/>
+          <p:cNvSpPr>
+            <a:spLocks noGrp="1" noRot="1" noChangeAspect="1"/>
+          </p:cNvSpPr>
+          <p:nvPr>
+            <p:ph type="sldImg"/>
+          </p:nvPr>
+        </p:nvSpPr>
+        <p:spPr/>
+      </p:sp>
+      <p:sp>
+        <p:nvSpPr>
+          <p:cNvPr id="3" name="Notes Placeholder 2"/>
+          <p:cNvSpPr>
+            <a:spLocks noGrp="1"/>
+          </p:cNvSpPr>
+          <p:nvPr>
+            <p:ph type="body" idx="1"/>
+          </p:nvPr>
+        </p:nvSpPr>
+        <p:spPr/>
+        <p:txBody>
+          <a:bodyPr/>
+          <a:lstStyle/>
+          <a:p>
+            <a:r>
+              <a:rPr lang="en-US" dirty="0"/>
+              <a:t/>
+            </a:r>
+            <a:endParaRPr lang="en-US" dirty="0"/>
+          </a:p>
+        </p:txBody>
+      </p:sp>
+      <p:sp>
+        <p:nvSpPr>
+          <p:cNvPr id="4" name="Slide Number Placeholder 3"/>
+          <p:cNvSpPr>
+            <a:spLocks noGrp="1"/>
+          </p:cNvSpPr>
+          <p:nvPr>
+            <p:ph type="sldNum" sz="quarter" idx="10"/>
+          </p:nvPr>
+        </p:nvSpPr>
+        <p:spPr/>
+        <p:txBody>
+          <a:bodyPr/>
+          <a:lstStyle/>
+          <a:p>
+            <a:fld id="{F7021451-1387-4CA6-816F-3879F97B5CBC}" type="slidenum">
+              <a:rPr lang="en-US"/>
+              <a:t>11</a:t>
             </a:fld>
             <a:endParaRPr lang="en-US"/>
           </a:p>
@@ -1684,7 +1773,7 @@
         </p:nvSpPr>
         <p:spPr>
           <a:xfrm>
-            <a:off x="0" y="5394960"/>
+            <a:off x="0" y="5349240"/>
             <a:ext cx="12191695" cy="54864"/>
           </a:xfrm>
           <a:prstGeom prst="rect">
@@ -1821,7 +1910,7 @@
         </p:nvSpPr>
         <p:spPr>
           <a:xfrm>
-            <a:off x="822960" y="5669280"/>
+            <a:off x="822960" y="5623560"/>
             <a:ext cx="10058400" cy="914400"/>
           </a:xfrm>
           <a:prstGeom prst="rect">
@@ -1849,7 +1938,7 @@
                 <a:ea typeface="맑은 고딕" pitchFamily="34" charset="-122"/>
                 <a:cs typeface="맑은 고딕" pitchFamily="34" charset="-120"/>
               </a:rPr>
-              <a:t>AI 모호성 검출 · 해결 데모까지 구현 / 테스트 완료</a:t>
+              <a:t>모호성 검출·해결 데모까지 구현 / 테스트 완료</a:t>
             </a:r>
             <a:endParaRPr lang="en-US" sz="1500" dirty="0"/>
           </a:p>
@@ -1880,7 +1969,7 @@
         </p:nvSpPr>
         <p:spPr>
           <a:xfrm>
-            <a:off x="9509760" y="5989320"/>
+            <a:off x="9509760" y="5943600"/>
             <a:ext cx="2194560" cy="365760"/>
           </a:xfrm>
           <a:prstGeom prst="rect">
@@ -1922,6 +2011,566 @@
 <file path=ppt/slides/slide10.xml><?xml version="1.0" encoding="utf-8"?>
 <p:sld xmlns:a="http://schemas.openxmlformats.org/drawingml/2006/main" xmlns:r="http://schemas.openxmlformats.org/officeDocument/2006/relationships" xmlns:p="http://schemas.openxmlformats.org/presentationml/2006/main">
   <p:cSld name="Slide 10">
+    <p:bg>
+      <p:bgPr>
+        <a:solidFill>
+          <a:srgbClr val="F5F7FA"/>
+        </a:solidFill>
+      </p:bgPr>
+    </p:bg>
+    <p:spTree>
+      <p:nvGrpSpPr>
+        <p:cNvPr id="1" name=""/>
+        <p:cNvGrpSpPr/>
+        <p:nvPr/>
+      </p:nvGrpSpPr>
+      <p:grpSpPr>
+        <a:xfrm>
+          <a:off x="0" y="0"/>
+          <a:ext cx="0" cy="0"/>
+          <a:chOff x="0" y="0"/>
+          <a:chExt cx="0" cy="0"/>
+        </a:xfrm>
+      </p:grpSpPr>
+      <p:sp>
+        <p:nvSpPr>
+          <p:cNvPr id="2" name="Text 0"/>
+          <p:cNvSpPr/>
+          <p:nvPr/>
+        </p:nvSpPr>
+        <p:spPr>
+          <a:xfrm>
+            <a:off x="566928" y="201168"/>
+            <a:ext cx="8229600" cy="274320"/>
+          </a:xfrm>
+          <a:prstGeom prst="rect">
+            <a:avLst/>
+          </a:prstGeom>
+          <a:noFill/>
+          <a:ln/>
+        </p:spPr>
+        <p:txBody>
+          <a:bodyPr wrap="square" rtlCol="0" anchor="ctr"/>
+          <a:lstStyle/>
+          <a:p>
+            <a:pPr indent="0" marL="0">
+              <a:buNone/>
+            </a:pPr>
+            <a:r>
+              <a:rPr lang="en-US" sz="1200" b="1" spc="200" kern="0" dirty="0">
+                <a:solidFill>
+                  <a:srgbClr val="C67F17"/>
+                </a:solidFill>
+                <a:latin typeface="맑은 고딕" pitchFamily="34" charset="0"/>
+                <a:ea typeface="맑은 고딕" pitchFamily="34" charset="-122"/>
+                <a:cs typeface="맑은 고딕" pitchFamily="34" charset="-120"/>
+              </a:rPr>
+              <a:t>ISSUE</a:t>
+            </a:r>
+            <a:endParaRPr lang="en-US" sz="1200" dirty="0"/>
+          </a:p>
+        </p:txBody>
+      </p:sp>
+      <p:sp>
+        <p:nvSpPr>
+          <p:cNvPr id="3" name="Text 1"/>
+          <p:cNvSpPr/>
+          <p:nvPr/>
+        </p:nvSpPr>
+        <p:spPr>
+          <a:xfrm>
+            <a:off x="548640" y="457200"/>
+            <a:ext cx="10424160" cy="658368"/>
+          </a:xfrm>
+          <a:prstGeom prst="rect">
+            <a:avLst/>
+          </a:prstGeom>
+          <a:noFill/>
+          <a:ln/>
+        </p:spPr>
+        <p:txBody>
+          <a:bodyPr wrap="square" rtlCol="0" anchor="ctr"/>
+          <a:lstStyle/>
+          <a:p>
+            <a:pPr indent="0" marL="0">
+              <a:buNone/>
+            </a:pPr>
+            <a:r>
+              <a:rPr lang="en-US" sz="2800" b="1" dirty="0">
+                <a:solidFill>
+                  <a:srgbClr val="1B2A4A"/>
+                </a:solidFill>
+                <a:latin typeface="맑은 고딕" pitchFamily="34" charset="0"/>
+                <a:ea typeface="맑은 고딕" pitchFamily="34" charset="-122"/>
+                <a:cs typeface="맑은 고딕" pitchFamily="34" charset="-120"/>
+              </a:rPr>
+              <a:t>발견된 이슈 &amp; 해결 방향</a:t>
+            </a:r>
+            <a:endParaRPr lang="en-US" sz="2800" dirty="0"/>
+          </a:p>
+        </p:txBody>
+      </p:sp>
+      <p:sp>
+        <p:nvSpPr>
+          <p:cNvPr id="4" name="Text 2"/>
+          <p:cNvSpPr/>
+          <p:nvPr/>
+        </p:nvSpPr>
+        <p:spPr>
+          <a:xfrm>
+            <a:off x="11109960" y="457200"/>
+            <a:ext cx="685800" cy="658368"/>
+          </a:xfrm>
+          <a:prstGeom prst="rect">
+            <a:avLst/>
+          </a:prstGeom>
+          <a:noFill/>
+          <a:ln/>
+        </p:spPr>
+        <p:txBody>
+          <a:bodyPr wrap="square" rtlCol="0" anchor="ctr"/>
+          <a:lstStyle/>
+          <a:p>
+            <a:pPr algn="r" indent="0" marL="0">
+              <a:buNone/>
+            </a:pPr>
+            <a:r>
+              <a:rPr lang="en-US" sz="1900" b="1" dirty="0">
+                <a:solidFill>
+                  <a:srgbClr val="C67F17"/>
+                </a:solidFill>
+                <a:latin typeface="맑은 고딕" pitchFamily="34" charset="0"/>
+                <a:ea typeface="맑은 고딕" pitchFamily="34" charset="-122"/>
+                <a:cs typeface="맑은 고딕" pitchFamily="34" charset="-120"/>
+              </a:rPr>
+              <a:t>10</a:t>
+            </a:r>
+            <a:endParaRPr lang="en-US" sz="1900" dirty="0"/>
+          </a:p>
+        </p:txBody>
+      </p:sp>
+      <p:sp>
+        <p:nvSpPr>
+          <p:cNvPr id="5" name="Shape 3"/>
+          <p:cNvSpPr/>
+          <p:nvPr/>
+        </p:nvSpPr>
+        <p:spPr>
+          <a:xfrm>
+            <a:off x="566928" y="1417320"/>
+            <a:ext cx="11064240" cy="1828800"/>
+          </a:xfrm>
+          <a:prstGeom prst="roundRect">
+            <a:avLst>
+              <a:gd name="adj" fmla="val 4000"/>
+            </a:avLst>
+          </a:prstGeom>
+          <a:solidFill>
+            <a:srgbClr val="FBEDEC"/>
+          </a:solidFill>
+          <a:ln w="12700">
+            <a:solidFill>
+              <a:srgbClr val="DCE3EB"/>
+            </a:solidFill>
+            <a:prstDash val="solid"/>
+          </a:ln>
+          <a:effectLst>
+            <a:outerShdw sx="100000" sy="100000" kx="0" ky="0" algn="bl" rotWithShape="0" blurRad="76200" dist="25400" dir="5400000">
+              <a:srgbClr val="B9C3CE">
+                <a:alpha val="35000"/>
+              </a:srgbClr>
+            </a:outerShdw>
+          </a:effectLst>
+        </p:spPr>
+      </p:sp>
+      <p:sp>
+        <p:nvSpPr>
+          <p:cNvPr id="6" name="Text 4"/>
+          <p:cNvSpPr/>
+          <p:nvPr/>
+        </p:nvSpPr>
+        <p:spPr>
+          <a:xfrm>
+            <a:off x="868680" y="1600200"/>
+            <a:ext cx="10515600" cy="457200"/>
+          </a:xfrm>
+          <a:prstGeom prst="rect">
+            <a:avLst/>
+          </a:prstGeom>
+          <a:noFill/>
+          <a:ln/>
+        </p:spPr>
+        <p:txBody>
+          <a:bodyPr wrap="square" rtlCol="0" anchor="ctr"/>
+          <a:lstStyle/>
+          <a:p>
+            <a:pPr indent="0" marL="0">
+              <a:buNone/>
+            </a:pPr>
+            <a:r>
+              <a:rPr lang="en-US" sz="1800" b="1" dirty="0">
+                <a:solidFill>
+                  <a:srgbClr val="C0503F"/>
+                </a:solidFill>
+                <a:latin typeface="맑은 고딕" pitchFamily="34" charset="0"/>
+                <a:ea typeface="맑은 고딕" pitchFamily="34" charset="-122"/>
+                <a:cs typeface="맑은 고딕" pitchFamily="34" charset="-120"/>
+              </a:rPr>
+              <a:t>★  실제 명세서 docx 파싱 실패  —  "file is not a zip file"</a:t>
+            </a:r>
+            <a:endParaRPr lang="en-US" sz="1800" dirty="0"/>
+          </a:p>
+        </p:txBody>
+      </p:sp>
+      <p:sp>
+        <p:nvSpPr>
+          <p:cNvPr id="7" name="Text 5"/>
+          <p:cNvSpPr/>
+          <p:nvPr/>
+        </p:nvSpPr>
+        <p:spPr>
+          <a:xfrm>
+            <a:off x="868680" y="2103120"/>
+            <a:ext cx="10515600" cy="1005840"/>
+          </a:xfrm>
+          <a:prstGeom prst="rect">
+            <a:avLst/>
+          </a:prstGeom>
+          <a:noFill/>
+          <a:ln/>
+        </p:spPr>
+        <p:txBody>
+          <a:bodyPr wrap="square" rtlCol="0" anchor="t"/>
+          <a:lstStyle/>
+          <a:p>
+            <a:pPr marL="177800" indent="-177800">
+              <a:spcAft>
+                <a:spcPts val="800"/>
+              </a:spcAft>
+              <a:buSzPct val="100000"/>
+              <a:buChar char="•"/>
+            </a:pPr>
+            <a:r>
+              <a:rPr lang="en-US" sz="1500" dirty="0">
+                <a:solidFill>
+                  <a:srgbClr val="5A3A36"/>
+                </a:solidFill>
+                <a:latin typeface="맑은 고딕" pitchFamily="34" charset="0"/>
+                <a:ea typeface="맑은 고딕" pitchFamily="34" charset="-122"/>
+                <a:cs typeface="맑은 고딕" pitchFamily="34" charset="-120"/>
+              </a:rPr>
+              <a:t>원인 추정: 문서보안(DRM)·암호 또는 한글(hwp)·구버전(.doc) → raw 파일이 zip 아님 (Word에선 열려도)</a:t>
+            </a:r>
+            <a:endParaRPr lang="en-US" sz="1500" dirty="0"/>
+          </a:p>
+          <a:p>
+            <a:pPr marL="177800" indent="-177800">
+              <a:spcAft>
+                <a:spcPts val="800"/>
+              </a:spcAft>
+              <a:buSzPct val="100000"/>
+              <a:buChar char="•"/>
+            </a:pPr>
+            <a:r>
+              <a:rPr lang="en-US" sz="1500" dirty="0">
+                <a:solidFill>
+                  <a:srgbClr val="2A8A57"/>
+                </a:solidFill>
+                <a:latin typeface="맑은 고딕" pitchFamily="34" charset="0"/>
+                <a:ea typeface="맑은 고딕" pitchFamily="34" charset="-122"/>
+                <a:cs typeface="맑은 고딕" pitchFamily="34" charset="-120"/>
+              </a:rPr>
+              <a:t>해결방향: 실제 파일 시그니처 확인 중 / 보안 해제 사본 테스트 / hwp면 hwp 파싱 지원 검토</a:t>
+            </a:r>
+            <a:endParaRPr lang="en-US" sz="1500" dirty="0"/>
+          </a:p>
+        </p:txBody>
+      </p:sp>
+      <p:sp>
+        <p:nvSpPr>
+          <p:cNvPr id="8" name="Shape 6"/>
+          <p:cNvSpPr/>
+          <p:nvPr/>
+        </p:nvSpPr>
+        <p:spPr>
+          <a:xfrm>
+            <a:off x="566928" y="3429000"/>
+            <a:ext cx="5440680" cy="2148840"/>
+          </a:xfrm>
+          <a:prstGeom prst="roundRect">
+            <a:avLst>
+              <a:gd name="adj" fmla="val 3404"/>
+            </a:avLst>
+          </a:prstGeom>
+          <a:solidFill>
+            <a:srgbClr val="FFFFFF"/>
+          </a:solidFill>
+          <a:ln w="12700">
+            <a:solidFill>
+              <a:srgbClr val="DCE3EB"/>
+            </a:solidFill>
+            <a:prstDash val="solid"/>
+          </a:ln>
+          <a:effectLst>
+            <a:outerShdw sx="100000" sy="100000" kx="0" ky="0" algn="bl" rotWithShape="0" blurRad="76200" dist="25400" dir="5400000">
+              <a:srgbClr val="B9C3CE">
+                <a:alpha val="35000"/>
+              </a:srgbClr>
+            </a:outerShdw>
+          </a:effectLst>
+        </p:spPr>
+      </p:sp>
+      <p:sp>
+        <p:nvSpPr>
+          <p:cNvPr id="9" name="Text 7"/>
+          <p:cNvSpPr/>
+          <p:nvPr/>
+        </p:nvSpPr>
+        <p:spPr>
+          <a:xfrm>
+            <a:off x="822960" y="3611880"/>
+            <a:ext cx="4937760" cy="457200"/>
+          </a:xfrm>
+          <a:prstGeom prst="rect">
+            <a:avLst/>
+          </a:prstGeom>
+          <a:noFill/>
+          <a:ln/>
+        </p:spPr>
+        <p:txBody>
+          <a:bodyPr wrap="square" rtlCol="0" anchor="ctr"/>
+          <a:lstStyle/>
+          <a:p>
+            <a:pPr indent="0" marL="0">
+              <a:buNone/>
+            </a:pPr>
+            <a:r>
+              <a:rPr lang="en-US" sz="1700" b="1" dirty="0">
+                <a:solidFill>
+                  <a:srgbClr val="C67F17"/>
+                </a:solidFill>
+                <a:latin typeface="맑은 고딕" pitchFamily="34" charset="0"/>
+                <a:ea typeface="맑은 고딕" pitchFamily="34" charset="-122"/>
+                <a:cs typeface="맑은 고딕" pitchFamily="34" charset="-120"/>
+              </a:rPr>
+              <a:t>모호성 과검출</a:t>
+            </a:r>
+            <a:endParaRPr lang="en-US" sz="1700" dirty="0"/>
+          </a:p>
+        </p:txBody>
+      </p:sp>
+      <p:sp>
+        <p:nvSpPr>
+          <p:cNvPr id="10" name="Text 8"/>
+          <p:cNvSpPr/>
+          <p:nvPr/>
+        </p:nvSpPr>
+        <p:spPr>
+          <a:xfrm>
+            <a:off x="868680" y="4114800"/>
+            <a:ext cx="4846320" cy="1280160"/>
+          </a:xfrm>
+          <a:prstGeom prst="rect">
+            <a:avLst/>
+          </a:prstGeom>
+          <a:noFill/>
+          <a:ln/>
+        </p:spPr>
+        <p:txBody>
+          <a:bodyPr wrap="square" rtlCol="0" anchor="t"/>
+          <a:lstStyle/>
+          <a:p>
+            <a:pPr marL="177800" indent="-177800">
+              <a:spcAft>
+                <a:spcPts val="800"/>
+              </a:spcAft>
+              <a:buSzPct val="100000"/>
+              <a:buChar char="•"/>
+            </a:pPr>
+            <a:r>
+              <a:rPr lang="en-US" sz="1500" dirty="0">
+                <a:solidFill>
+                  <a:srgbClr val="1F2733"/>
+                </a:solidFill>
+                <a:latin typeface="맑은 고딕" pitchFamily="34" charset="0"/>
+                <a:ea typeface="맑은 고딕" pitchFamily="34" charset="-122"/>
+                <a:cs typeface="맑은 고딕" pitchFamily="34" charset="-120"/>
+              </a:rPr>
+              <a:t>사소한 표현까지 잡는 경향</a:t>
+            </a:r>
+            <a:endParaRPr lang="en-US" sz="1500" dirty="0"/>
+          </a:p>
+          <a:p>
+            <a:pPr marL="177800" indent="-177800">
+              <a:spcAft>
+                <a:spcPts val="800"/>
+              </a:spcAft>
+              <a:buSzPct val="100000"/>
+              <a:buChar char="•"/>
+            </a:pPr>
+            <a:r>
+              <a:rPr lang="en-US" sz="1500" dirty="0">
+                <a:solidFill>
+                  <a:srgbClr val="1F2733"/>
+                </a:solidFill>
+                <a:latin typeface="맑은 고딕" pitchFamily="34" charset="0"/>
+                <a:ea typeface="맑은 고딕" pitchFamily="34" charset="-122"/>
+                <a:cs typeface="맑은 고딕" pitchFamily="34" charset="-120"/>
+              </a:rPr>
+              <a:t>→ 도메인 지식·기준 프롬프트 정교화로 완화</a:t>
+            </a:r>
+            <a:endParaRPr lang="en-US" sz="1500" dirty="0"/>
+          </a:p>
+        </p:txBody>
+      </p:sp>
+      <p:sp>
+        <p:nvSpPr>
+          <p:cNvPr id="11" name="Shape 9"/>
+          <p:cNvSpPr/>
+          <p:nvPr/>
+        </p:nvSpPr>
+        <p:spPr>
+          <a:xfrm>
+            <a:off x="6199632" y="3429000"/>
+            <a:ext cx="5440680" cy="2148840"/>
+          </a:xfrm>
+          <a:prstGeom prst="roundRect">
+            <a:avLst>
+              <a:gd name="adj" fmla="val 3404"/>
+            </a:avLst>
+          </a:prstGeom>
+          <a:solidFill>
+            <a:srgbClr val="FFFFFF"/>
+          </a:solidFill>
+          <a:ln w="12700">
+            <a:solidFill>
+              <a:srgbClr val="DCE3EB"/>
+            </a:solidFill>
+            <a:prstDash val="solid"/>
+          </a:ln>
+          <a:effectLst>
+            <a:outerShdw sx="100000" sy="100000" kx="0" ky="0" algn="bl" rotWithShape="0" blurRad="76200" dist="25400" dir="5400000">
+              <a:srgbClr val="B9C3CE">
+                <a:alpha val="35000"/>
+              </a:srgbClr>
+            </a:outerShdw>
+          </a:effectLst>
+        </p:spPr>
+      </p:sp>
+      <p:sp>
+        <p:nvSpPr>
+          <p:cNvPr id="12" name="Text 10"/>
+          <p:cNvSpPr/>
+          <p:nvPr/>
+        </p:nvSpPr>
+        <p:spPr>
+          <a:xfrm>
+            <a:off x="6446520" y="3611880"/>
+            <a:ext cx="4937760" cy="457200"/>
+          </a:xfrm>
+          <a:prstGeom prst="rect">
+            <a:avLst/>
+          </a:prstGeom>
+          <a:noFill/>
+          <a:ln/>
+        </p:spPr>
+        <p:txBody>
+          <a:bodyPr wrap="square" rtlCol="0" anchor="ctr"/>
+          <a:lstStyle/>
+          <a:p>
+            <a:pPr indent="0" marL="0">
+              <a:buNone/>
+            </a:pPr>
+            <a:r>
+              <a:rPr lang="en-US" sz="1700" b="1" dirty="0">
+                <a:solidFill>
+                  <a:srgbClr val="24395F"/>
+                </a:solidFill>
+                <a:latin typeface="맑은 고딕" pitchFamily="34" charset="0"/>
+                <a:ea typeface="맑은 고딕" pitchFamily="34" charset="-122"/>
+                <a:cs typeface="맑은 고딕" pitchFamily="34" charset="-120"/>
+              </a:rPr>
+              <a:t>다음 단계</a:t>
+            </a:r>
+            <a:endParaRPr lang="en-US" sz="1700" dirty="0"/>
+          </a:p>
+        </p:txBody>
+      </p:sp>
+      <p:sp>
+        <p:nvSpPr>
+          <p:cNvPr id="13" name="Text 11"/>
+          <p:cNvSpPr/>
+          <p:nvPr/>
+        </p:nvSpPr>
+        <p:spPr>
+          <a:xfrm>
+            <a:off x="6492240" y="4114800"/>
+            <a:ext cx="4846320" cy="1280160"/>
+          </a:xfrm>
+          <a:prstGeom prst="rect">
+            <a:avLst/>
+          </a:prstGeom>
+          <a:noFill/>
+          <a:ln/>
+        </p:spPr>
+        <p:txBody>
+          <a:bodyPr wrap="square" rtlCol="0" anchor="t"/>
+          <a:lstStyle/>
+          <a:p>
+            <a:pPr marL="177800" indent="-177800">
+              <a:spcAft>
+                <a:spcPts val="800"/>
+              </a:spcAft>
+              <a:buSzPct val="100000"/>
+              <a:buChar char="•"/>
+            </a:pPr>
+            <a:r>
+              <a:rPr lang="en-US" sz="1500" dirty="0">
+                <a:solidFill>
+                  <a:srgbClr val="1F2733"/>
+                </a:solidFill>
+                <a:latin typeface="맑은 고딕" pitchFamily="34" charset="0"/>
+                <a:ea typeface="맑은 고딕" pitchFamily="34" charset="-122"/>
+                <a:cs typeface="맑은 고딕" pitchFamily="34" charset="-120"/>
+              </a:rPr>
+              <a:t>docx(→hwp) 입력 문제 해결 우선</a:t>
+            </a:r>
+            <a:endParaRPr lang="en-US" sz="1500" dirty="0"/>
+          </a:p>
+          <a:p>
+            <a:pPr marL="177800" indent="-177800">
+              <a:spcAft>
+                <a:spcPts val="800"/>
+              </a:spcAft>
+              <a:buSzPct val="100000"/>
+              <a:buChar char="•"/>
+            </a:pPr>
+            <a:r>
+              <a:rPr lang="en-US" sz="1500" dirty="0">
+                <a:solidFill>
+                  <a:srgbClr val="1F2733"/>
+                </a:solidFill>
+                <a:latin typeface="맑은 고딕" pitchFamily="34" charset="0"/>
+                <a:ea typeface="맑은 고딕" pitchFamily="34" charset="-122"/>
+                <a:cs typeface="맑은 고딕" pitchFamily="34" charset="-120"/>
+              </a:rPr>
+              <a:t>기능 도출·DB 동기화·백엔드 확장 구현</a:t>
+            </a:r>
+            <a:endParaRPr lang="en-US" sz="1500" dirty="0"/>
+          </a:p>
+        </p:txBody>
+      </p:sp>
+    </p:spTree>
+  </p:cSld>
+  <p:clrMapOvr>
+    <a:masterClrMapping/>
+  </p:clrMapOvr>
+</p:sld>
+</file>
+
+<file path=ppt/slides/slide11.xml><?xml version="1.0" encoding="utf-8"?>
+<p:sld xmlns:a="http://schemas.openxmlformats.org/drawingml/2006/main" xmlns:r="http://schemas.openxmlformats.org/officeDocument/2006/relationships" xmlns:p="http://schemas.openxmlformats.org/presentationml/2006/main">
+  <p:cSld name="Slide 11">
     <p:bg>
       <p:bgPr>
         <a:solidFill>
@@ -2030,7 +2679,7 @@
               <a:buNone/>
             </a:pPr>
             <a:r>
-              <a:rPr lang="en-US" sz="2700" b="1" dirty="0">
+              <a:rPr lang="en-US" sz="2600" b="1" dirty="0">
                 <a:solidFill>
                   <a:srgbClr val="FFFFFF"/>
                 </a:solidFill>
@@ -2040,7 +2689,7 @@
               </a:rPr>
               <a:t>모호성 검출·해결 데모까지 구현 완료,</a:t>
             </a:r>
-            <a:endParaRPr lang="en-US" sz="2700" dirty="0"/>
+            <a:endParaRPr lang="en-US" sz="2600" dirty="0"/>
           </a:p>
           <a:p>
             <a:pPr indent="0" marL="0">
@@ -2050,7 +2699,7 @@
               <a:buNone/>
             </a:pPr>
             <a:r>
-              <a:rPr lang="en-US" sz="2700" b="1" dirty="0">
+              <a:rPr lang="en-US" sz="2600" b="1" dirty="0">
                 <a:solidFill>
                   <a:srgbClr val="FFFFFF"/>
                 </a:solidFill>
@@ -2060,7 +2709,7 @@
               </a:rPr>
               <a:t>docx 문서보안 이슈만 풀면 실제 명세서 투입 가능</a:t>
             </a:r>
-            <a:endParaRPr lang="en-US" sz="2700" dirty="0"/>
+            <a:endParaRPr lang="en-US" sz="2600" dirty="0"/>
           </a:p>
         </p:txBody>
       </p:sp>
@@ -2073,7 +2722,7 @@
         <p:spPr>
           <a:xfrm>
             <a:off x="822960" y="3657600"/>
-            <a:ext cx="10515600" cy="2286000"/>
+            <a:ext cx="10515600" cy="2103120"/>
           </a:xfrm>
           <a:prstGeom prst="rect">
             <a:avLst/>
@@ -2087,7 +2736,7 @@
           <a:p>
             <a:pPr marL="177800" indent="-177800">
               <a:spcAft>
-                <a:spcPts val="900"/>
+                <a:spcPts val="800"/>
               </a:spcAft>
               <a:buSzPct val="100000"/>
               <a:buChar char="•"/>
@@ -2101,14 +2750,14 @@
                 <a:ea typeface="맑은 고딕" pitchFamily="34" charset="-122"/>
                 <a:cs typeface="맑은 고딕" pitchFamily="34" charset="-120"/>
               </a:rPr>
-              <a:t>구현·테스트: 모호성 해결 웹 데모, docx 업로드 파싱</a:t>
+              <a:t>구현·테스트: 모호성 해결 웹 데모 (docx 업로드 → 검출 → 해결)</a:t>
             </a:r>
             <a:endParaRPr lang="en-US" sz="1500" dirty="0"/>
           </a:p>
           <a:p>
             <a:pPr marL="177800" indent="-177800">
               <a:spcAft>
-                <a:spcPts val="900"/>
+                <a:spcPts val="800"/>
               </a:spcAft>
               <a:buSzPct val="100000"/>
               <a:buChar char="•"/>
@@ -2122,14 +2771,14 @@
                 <a:ea typeface="맑은 고딕" pitchFamily="34" charset="-122"/>
                 <a:cs typeface="맑은 고딕" pitchFamily="34" charset="-120"/>
               </a:rPr>
-              <a:t>이슈: 실제 docx(DRM/hwp) 파싱 — 해결 방향 논의 필요</a:t>
+              <a:t>설계: 기능 도출(UI·APP 명세), DB 스키마 동기화(pull)</a:t>
             </a:r>
             <a:endParaRPr lang="en-US" sz="1500" dirty="0"/>
           </a:p>
           <a:p>
             <a:pPr marL="177800" indent="-177800">
               <a:spcAft>
-                <a:spcPts val="900"/>
+                <a:spcPts val="800"/>
               </a:spcAft>
               <a:buSzPct val="100000"/>
               <a:buChar char="•"/>
@@ -2143,7 +2792,7 @@
                 <a:ea typeface="맑은 고딕" pitchFamily="34" charset="-122"/>
                 <a:cs typeface="맑은 고딕" pitchFamily="34" charset="-120"/>
               </a:rPr>
-              <a:t>다음: 입력 형식 해결 후 기능 도출·백엔드 확장</a:t>
+              <a:t>이슈: 실제 docx(DRM/hwp) 파싱 — 해결 방향 논의 필요</a:t>
             </a:r>
             <a:endParaRPr lang="en-US" sz="1500" dirty="0"/>
           </a:p>
@@ -2228,8 +2877,8 @@
         </p:nvSpPr>
         <p:spPr>
           <a:xfrm>
-            <a:off x="566928" y="182880"/>
-            <a:ext cx="7315200" cy="274320"/>
+            <a:off x="566928" y="201168"/>
+            <a:ext cx="8229600" cy="274320"/>
           </a:xfrm>
           <a:prstGeom prst="rect">
             <a:avLst/>
@@ -2267,8 +2916,8 @@
         </p:nvSpPr>
         <p:spPr>
           <a:xfrm>
-            <a:off x="548640" y="384048"/>
-            <a:ext cx="10424160" cy="640080"/>
+            <a:off x="548640" y="457200"/>
+            <a:ext cx="10424160" cy="658368"/>
           </a:xfrm>
           <a:prstGeom prst="rect">
             <a:avLst/>
@@ -2280,11 +2929,11 @@
           <a:bodyPr wrap="square" rtlCol="0" anchor="ctr"/>
           <a:lstStyle/>
           <a:p>
-            <a:pPr algn="l" indent="0" marL="0">
+            <a:pPr indent="0" marL="0">
               <a:buNone/>
             </a:pPr>
             <a:r>
-              <a:rPr lang="en-US" sz="3000" b="1" dirty="0">
+              <a:rPr lang="en-US" sz="2800" b="1" dirty="0">
                 <a:solidFill>
                   <a:srgbClr val="1B2A4A"/>
                 </a:solidFill>
@@ -2294,7 +2943,7 @@
               </a:rPr>
               <a:t>무엇을 만드나 — 핵심 기능 3가지</a:t>
             </a:r>
-            <a:endParaRPr lang="en-US" sz="3000" dirty="0"/>
+            <a:endParaRPr lang="en-US" sz="2800" dirty="0"/>
           </a:p>
         </p:txBody>
       </p:sp>
@@ -2306,8 +2955,8 @@
         </p:nvSpPr>
         <p:spPr>
           <a:xfrm>
-            <a:off x="11155680" y="384048"/>
-            <a:ext cx="640080" cy="640080"/>
+            <a:off x="11109960" y="457200"/>
+            <a:ext cx="685800" cy="658368"/>
           </a:xfrm>
           <a:prstGeom prst="rect">
             <a:avLst/>
@@ -2323,7 +2972,7 @@
               <a:buNone/>
             </a:pPr>
             <a:r>
-              <a:rPr lang="en-US" sz="2000" b="1" dirty="0">
+              <a:rPr lang="en-US" sz="1900" b="1" dirty="0">
                 <a:solidFill>
                   <a:srgbClr val="C67F17"/>
                 </a:solidFill>
@@ -2333,7 +2982,7 @@
               </a:rPr>
               <a:t>02</a:t>
             </a:r>
-            <a:endParaRPr lang="en-US" sz="2000" dirty="0"/>
+            <a:endParaRPr lang="en-US" sz="1900" dirty="0"/>
           </a:p>
         </p:txBody>
       </p:sp>
@@ -2345,7 +2994,7 @@
         </p:nvSpPr>
         <p:spPr>
           <a:xfrm>
-            <a:off x="566928" y="1170432"/>
+            <a:off x="566928" y="1234440"/>
             <a:ext cx="11064240" cy="457200"/>
           </a:xfrm>
           <a:prstGeom prst="rect">
@@ -2384,8 +3033,8 @@
         </p:nvSpPr>
         <p:spPr>
           <a:xfrm>
-            <a:off x="566928" y="1920240"/>
-            <a:ext cx="3520440" cy="3566160"/>
+            <a:off x="566928" y="1965960"/>
+            <a:ext cx="3520440" cy="3520440"/>
           </a:xfrm>
           <a:prstGeom prst="roundRect">
             <a:avLst>
@@ -2418,7 +3067,7 @@
         </p:nvSpPr>
         <p:spPr>
           <a:xfrm>
-            <a:off x="886968" y="2240280"/>
+            <a:off x="886968" y="2286000"/>
             <a:ext cx="640080" cy="640080"/>
           </a:xfrm>
           <a:prstGeom prst="ellipse">
@@ -2438,7 +3087,7 @@
         </p:nvSpPr>
         <p:spPr>
           <a:xfrm>
-            <a:off x="886968" y="2240280"/>
+            <a:off x="886968" y="2286000"/>
             <a:ext cx="640080" cy="640080"/>
           </a:xfrm>
           <a:prstGeom prst="rect">
@@ -2477,7 +3126,7 @@
         </p:nvSpPr>
         <p:spPr>
           <a:xfrm>
-            <a:off x="1664208" y="2286000"/>
+            <a:off x="1664208" y="2331720"/>
             <a:ext cx="2286000" cy="548640"/>
           </a:xfrm>
           <a:prstGeom prst="rect">
@@ -2516,7 +3165,7 @@
         </p:nvSpPr>
         <p:spPr>
           <a:xfrm>
-            <a:off x="886968" y="3200400"/>
+            <a:off x="886968" y="3246120"/>
             <a:ext cx="2926080" cy="1920240"/>
           </a:xfrm>
           <a:prstGeom prst="rect">
@@ -2531,7 +3180,7 @@
           <a:p>
             <a:pPr indent="0" marL="0">
               <a:lnSpc>
-                <a:spcPct val="115000"/>
+                <a:spcPct val="118000"/>
               </a:lnSpc>
               <a:buNone/>
             </a:pPr>
@@ -2544,7 +3193,7 @@
                 <a:ea typeface="맑은 고딕" pitchFamily="34" charset="-122"/>
                 <a:cs typeface="맑은 고딕" pitchFamily="34" charset="-120"/>
               </a:rPr>
-              <a:t>명세서에서 모호한 조항을 유형별로 검출하고, 합의를 거쳐 해석을 확정</a:t>
+              <a:t>docx 명세서에서 모호한 조항을 유형별로 검출하고, 합의를 거쳐 해석을 확정</a:t>
             </a:r>
             <a:endParaRPr lang="en-US" sz="1450" dirty="0"/>
           </a:p>
@@ -2558,8 +3207,8 @@
         </p:nvSpPr>
         <p:spPr>
           <a:xfrm>
-            <a:off x="4334256" y="1920240"/>
-            <a:ext cx="3520440" cy="3566160"/>
+            <a:off x="4334256" y="1965960"/>
+            <a:ext cx="3520440" cy="3520440"/>
           </a:xfrm>
           <a:prstGeom prst="roundRect">
             <a:avLst>
@@ -2592,7 +3241,7 @@
         </p:nvSpPr>
         <p:spPr>
           <a:xfrm>
-            <a:off x="4654296" y="2240280"/>
+            <a:off x="4654296" y="2286000"/>
             <a:ext cx="640080" cy="640080"/>
           </a:xfrm>
           <a:prstGeom prst="ellipse">
@@ -2612,7 +3261,7 @@
         </p:nvSpPr>
         <p:spPr>
           <a:xfrm>
-            <a:off x="4654296" y="2240280"/>
+            <a:off x="4654296" y="2286000"/>
             <a:ext cx="640080" cy="640080"/>
           </a:xfrm>
           <a:prstGeom prst="rect">
@@ -2651,7 +3300,7 @@
         </p:nvSpPr>
         <p:spPr>
           <a:xfrm>
-            <a:off x="5431536" y="2286000"/>
+            <a:off x="5431536" y="2331720"/>
             <a:ext cx="2286000" cy="548640"/>
           </a:xfrm>
           <a:prstGeom prst="rect">
@@ -2690,7 +3339,7 @@
         </p:nvSpPr>
         <p:spPr>
           <a:xfrm>
-            <a:off x="4654296" y="3200400"/>
+            <a:off x="4654296" y="3246120"/>
             <a:ext cx="2926080" cy="1920240"/>
           </a:xfrm>
           <a:prstGeom prst="rect">
@@ -2705,7 +3354,7 @@
           <a:p>
             <a:pPr indent="0" marL="0">
               <a:lnSpc>
-                <a:spcPct val="115000"/>
+                <a:spcPct val="118000"/>
               </a:lnSpc>
               <a:buNone/>
             </a:pPr>
@@ -2718,7 +3367,7 @@
                 <a:ea typeface="맑은 고딕" pitchFamily="34" charset="-122"/>
                 <a:cs typeface="맑은 고딕" pitchFamily="34" charset="-120"/>
               </a:rPr>
-              <a:t>확정된 요구사항을 실제 개발 단위 '기능'으로 분해 (UI · APP 명세)</a:t>
+              <a:t>확정된 요구사항을 개발 단위 '기능'으로 분해 → UI·APP 기능명세로 파생</a:t>
             </a:r>
             <a:endParaRPr lang="en-US" sz="1450" dirty="0"/>
           </a:p>
@@ -2732,8 +3381,8 @@
         </p:nvSpPr>
         <p:spPr>
           <a:xfrm>
-            <a:off x="8101584" y="1920240"/>
-            <a:ext cx="3520440" cy="3566160"/>
+            <a:off x="8101584" y="1965960"/>
+            <a:ext cx="3520440" cy="3520440"/>
           </a:xfrm>
           <a:prstGeom prst="roundRect">
             <a:avLst>
@@ -2766,7 +3415,7 @@
         </p:nvSpPr>
         <p:spPr>
           <a:xfrm>
-            <a:off x="8421624" y="2240280"/>
+            <a:off x="8421624" y="2286000"/>
             <a:ext cx="640080" cy="640080"/>
           </a:xfrm>
           <a:prstGeom prst="ellipse">
@@ -2786,7 +3435,7 @@
         </p:nvSpPr>
         <p:spPr>
           <a:xfrm>
-            <a:off x="8421624" y="2240280"/>
+            <a:off x="8421624" y="2286000"/>
             <a:ext cx="640080" cy="640080"/>
           </a:xfrm>
           <a:prstGeom prst="rect">
@@ -2825,7 +3474,7 @@
         </p:nvSpPr>
         <p:spPr>
           <a:xfrm>
-            <a:off x="9198864" y="2286000"/>
+            <a:off x="9198864" y="2331720"/>
             <a:ext cx="2286000" cy="548640"/>
           </a:xfrm>
           <a:prstGeom prst="rect">
@@ -2864,7 +3513,7 @@
         </p:nvSpPr>
         <p:spPr>
           <a:xfrm>
-            <a:off x="8421624" y="3200400"/>
+            <a:off x="8421624" y="3246120"/>
             <a:ext cx="2926080" cy="1920240"/>
           </a:xfrm>
           <a:prstGeom prst="rect">
@@ -2879,7 +3528,7 @@
           <a:p>
             <a:pPr indent="0" marL="0">
               <a:lnSpc>
-                <a:spcPct val="115000"/>
+                <a:spcPct val="118000"/>
               </a:lnSpc>
               <a:buNone/>
             </a:pPr>
@@ -2892,7 +3541,7 @@
                 <a:ea typeface="맑은 고딕" pitchFamily="34" charset="-122"/>
                 <a:cs typeface="맑은 고딕" pitchFamily="34" charset="-120"/>
               </a:rPr>
-              <a:t>테이블/컬럼/권한 변경을 등록·알림해 모두가 최신 DB 스키마 공유</a:t>
+              <a:t>최종 스키마 변경을 감지·알림하고, 클릭으로 개인 스키마에 동기화(pull)</a:t>
             </a:r>
             <a:endParaRPr lang="en-US" sz="1450" dirty="0"/>
           </a:p>
@@ -2931,7 +3580,7 @@
                 <a:ea typeface="맑은 고딕" pitchFamily="34" charset="-122"/>
                 <a:cs typeface="맑은 고딕" pitchFamily="34" charset="-120"/>
               </a:rPr>
-              <a:t>이번 공유: 핵심기능 ① 모호성 해결 위주로 구현·테스트, ③ DB 변경관리는 설계안까지</a:t>
+              <a:t>이번 공유: ① 모호성 해결은 구현·테스트 완료, ②·③은 설계 단계</a:t>
             </a:r>
             <a:endParaRPr lang="en-US" sz="1400" dirty="0"/>
           </a:p>
@@ -2977,8 +3626,8 @@
         </p:nvSpPr>
         <p:spPr>
           <a:xfrm>
-            <a:off x="566928" y="182880"/>
-            <a:ext cx="7315200" cy="274320"/>
+            <a:off x="566928" y="201168"/>
+            <a:ext cx="8229600" cy="274320"/>
           </a:xfrm>
           <a:prstGeom prst="rect">
             <a:avLst/>
@@ -3016,8 +3665,8 @@
         </p:nvSpPr>
         <p:spPr>
           <a:xfrm>
-            <a:off x="548640" y="384048"/>
-            <a:ext cx="10424160" cy="640080"/>
+            <a:off x="548640" y="457200"/>
+            <a:ext cx="10424160" cy="658368"/>
           </a:xfrm>
           <a:prstGeom prst="rect">
             <a:avLst/>
@@ -3029,11 +3678,11 @@
           <a:bodyPr wrap="square" rtlCol="0" anchor="ctr"/>
           <a:lstStyle/>
           <a:p>
-            <a:pPr algn="l" indent="0" marL="0">
+            <a:pPr indent="0" marL="0">
               <a:buNone/>
             </a:pPr>
             <a:r>
-              <a:rPr lang="en-US" sz="3000" b="1" dirty="0">
+              <a:rPr lang="en-US" sz="2800" b="1" dirty="0">
                 <a:solidFill>
                   <a:srgbClr val="1B2A4A"/>
                 </a:solidFill>
@@ -3041,9 +3690,9 @@
                 <a:ea typeface="맑은 고딕" pitchFamily="34" charset="-122"/>
                 <a:cs typeface="맑은 고딕" pitchFamily="34" charset="-120"/>
               </a:rPr>
-              <a:t>시스템 구성</a:t>
-            </a:r>
-            <a:endParaRPr lang="en-US" sz="3000" dirty="0"/>
+              <a:t>시스템 아키텍처</a:t>
+            </a:r>
+            <a:endParaRPr lang="en-US" sz="2800" dirty="0"/>
           </a:p>
         </p:txBody>
       </p:sp>
@@ -3055,8 +3704,8 @@
         </p:nvSpPr>
         <p:spPr>
           <a:xfrm>
-            <a:off x="11155680" y="384048"/>
-            <a:ext cx="640080" cy="640080"/>
+            <a:off x="11109960" y="457200"/>
+            <a:ext cx="685800" cy="658368"/>
           </a:xfrm>
           <a:prstGeom prst="rect">
             <a:avLst/>
@@ -3072,7 +3721,7 @@
               <a:buNone/>
             </a:pPr>
             <a:r>
-              <a:rPr lang="en-US" sz="2000" b="1" dirty="0">
+              <a:rPr lang="en-US" sz="1900" b="1" dirty="0">
                 <a:solidFill>
                   <a:srgbClr val="C67F17"/>
                 </a:solidFill>
@@ -3082,54 +3731,44 @@
               </a:rPr>
               <a:t>03</a:t>
             </a:r>
-            <a:endParaRPr lang="en-US" sz="2000" dirty="0"/>
-          </a:p>
-        </p:txBody>
-      </p:sp>
-      <p:sp>
-        <p:nvSpPr>
-          <p:cNvPr id="5" name="Shape 3"/>
-          <p:cNvSpPr/>
-          <p:nvPr/>
-        </p:nvSpPr>
-        <p:spPr>
-          <a:xfrm>
-            <a:off x="914400" y="1737360"/>
-            <a:ext cx="2926080" cy="1371600"/>
-          </a:xfrm>
-          <a:prstGeom prst="roundRect">
-            <a:avLst>
-              <a:gd name="adj" fmla="val 5333"/>
-            </a:avLst>
-          </a:prstGeom>
-          <a:solidFill>
-            <a:srgbClr val="FFFFFF"/>
-          </a:solidFill>
-          <a:ln w="12700">
-            <a:solidFill>
-              <a:srgbClr val="DCE3EB"/>
-            </a:solidFill>
-            <a:prstDash val="solid"/>
-          </a:ln>
-          <a:effectLst>
-            <a:outerShdw sx="100000" sy="100000" kx="0" ky="0" algn="bl" rotWithShape="0" blurRad="76200" dist="25400" dir="5400000">
-              <a:srgbClr val="B9C3CE">
-                <a:alpha val="35000"/>
-              </a:srgbClr>
-            </a:outerShdw>
-          </a:effectLst>
-        </p:spPr>
-      </p:sp>
-      <p:sp>
-        <p:nvSpPr>
-          <p:cNvPr id="6" name="Text 4"/>
-          <p:cNvSpPr/>
-          <p:nvPr/>
-        </p:nvSpPr>
-        <p:spPr>
-          <a:xfrm>
-            <a:off x="914400" y="1874520"/>
-            <a:ext cx="2926080" cy="548640"/>
+            <a:endParaRPr lang="en-US" sz="1900" dirty="0"/>
+          </a:p>
+        </p:txBody>
+      </p:sp>
+      <p:pic>
+        <p:nvPicPr>
+          <p:cNvPr id="5" name="Image 0" descr="/home/user/semes-superrookie/docs/img/design-arch.png">    </p:cNvPr>
+          <p:cNvPicPr>
+            <a:picLocks noChangeAspect="1"/>
+          </p:cNvPicPr>
+          <p:nvPr/>
+        </p:nvPicPr>
+        <p:blipFill>
+          <a:blip r:embed="rId1"/>
+          <a:stretch>
+            <a:fillRect/>
+          </a:stretch>
+        </p:blipFill>
+        <p:spPr>
+          <a:xfrm>
+            <a:off x="457200" y="1884426"/>
+            <a:ext cx="11292840" cy="3272028"/>
+          </a:xfrm>
+          <a:prstGeom prst="rect">
+            <a:avLst/>
+          </a:prstGeom>
+        </p:spPr>
+      </p:pic>
+      <p:sp>
+        <p:nvSpPr>
+          <p:cNvPr id="6" name="Text 3"/>
+          <p:cNvSpPr/>
+          <p:nvPr/>
+        </p:nvSpPr>
+        <p:spPr>
+          <a:xfrm>
+            <a:off x="566928" y="5989320"/>
+            <a:ext cx="11064240" cy="365760"/>
           </a:xfrm>
           <a:prstGeom prst="rect">
             <a:avLst/>
@@ -3141,50 +3780,11 @@
           <a:bodyPr wrap="square" rtlCol="0" anchor="ctr"/>
           <a:lstStyle/>
           <a:p>
-            <a:pPr algn="ctr" indent="0" marL="0">
+            <a:pPr indent="0" marL="0">
               <a:buNone/>
             </a:pPr>
             <a:r>
-              <a:rPr lang="en-US" sz="2200" b="1" dirty="0">
-                <a:solidFill>
-                  <a:srgbClr val="2C7A8C"/>
-                </a:solidFill>
-                <a:latin typeface="맑은 고딕" pitchFamily="34" charset="0"/>
-                <a:ea typeface="맑은 고딕" pitchFamily="34" charset="-122"/>
-                <a:cs typeface="맑은 고딕" pitchFamily="34" charset="-120"/>
-              </a:rPr>
-              <a:t>React</a:t>
-            </a:r>
-            <a:endParaRPr lang="en-US" sz="2200" dirty="0"/>
-          </a:p>
-        </p:txBody>
-      </p:sp>
-      <p:sp>
-        <p:nvSpPr>
-          <p:cNvPr id="7" name="Text 5"/>
-          <p:cNvSpPr/>
-          <p:nvPr/>
-        </p:nvSpPr>
-        <p:spPr>
-          <a:xfrm>
-            <a:off x="914400" y="2468880"/>
-            <a:ext cx="2926080" cy="457200"/>
-          </a:xfrm>
-          <a:prstGeom prst="rect">
-            <a:avLst/>
-          </a:prstGeom>
-          <a:noFill/>
-          <a:ln/>
-        </p:spPr>
-        <p:txBody>
-          <a:bodyPr wrap="square" rtlCol="0" anchor="ctr"/>
-          <a:lstStyle/>
-          <a:p>
-            <a:pPr algn="ctr" indent="0" marL="0">
-              <a:buNone/>
-            </a:pPr>
-            <a:r>
-              <a:rPr lang="en-US" sz="1400" dirty="0">
+              <a:rPr lang="en-US" sz="1300" i="1" dirty="0">
                 <a:solidFill>
                   <a:srgbClr val="63707E"/>
                 </a:solidFill>
@@ -3192,451 +3792,9 @@
                 <a:ea typeface="맑은 고딕" pitchFamily="34" charset="-122"/>
                 <a:cs typeface="맑은 고딕" pitchFamily="34" charset="-120"/>
               </a:rPr>
-              <a:t>프론트엔드</a:t>
-            </a:r>
-            <a:endParaRPr lang="en-US" sz="1400" dirty="0"/>
-          </a:p>
-        </p:txBody>
-      </p:sp>
-      <p:sp>
-        <p:nvSpPr>
-          <p:cNvPr id="8" name="Text 6"/>
-          <p:cNvSpPr/>
-          <p:nvPr/>
-        </p:nvSpPr>
-        <p:spPr>
-          <a:xfrm>
-            <a:off x="3840480" y="1737360"/>
-            <a:ext cx="731520" cy="1371600"/>
-          </a:xfrm>
-          <a:prstGeom prst="rect">
-            <a:avLst/>
-          </a:prstGeom>
-          <a:noFill/>
-          <a:ln/>
-        </p:spPr>
-        <p:txBody>
-          <a:bodyPr wrap="square" rtlCol="0" anchor="ctr"/>
-          <a:lstStyle/>
-          <a:p>
-            <a:pPr algn="ctr" indent="0" marL="0">
-              <a:buNone/>
-            </a:pPr>
-            <a:r>
-              <a:rPr lang="en-US" sz="3000" b="1" dirty="0">
-                <a:solidFill>
-                  <a:srgbClr val="9AA6B2"/>
-                </a:solidFill>
-                <a:latin typeface="맑은 고딕" pitchFamily="34" charset="0"/>
-                <a:ea typeface="맑은 고딕" pitchFamily="34" charset="-122"/>
-                <a:cs typeface="맑은 고딕" pitchFamily="34" charset="-120"/>
-              </a:rPr>
-              <a:t>→</a:t>
-            </a:r>
-            <a:endParaRPr lang="en-US" sz="3000" dirty="0"/>
-          </a:p>
-        </p:txBody>
-      </p:sp>
-      <p:sp>
-        <p:nvSpPr>
-          <p:cNvPr id="9" name="Shape 7"/>
-          <p:cNvSpPr/>
-          <p:nvPr/>
-        </p:nvSpPr>
-        <p:spPr>
-          <a:xfrm>
-            <a:off x="4572000" y="1737360"/>
-            <a:ext cx="2926080" cy="1371600"/>
-          </a:xfrm>
-          <a:prstGeom prst="roundRect">
-            <a:avLst>
-              <a:gd name="adj" fmla="val 5333"/>
-            </a:avLst>
-          </a:prstGeom>
-          <a:solidFill>
-            <a:srgbClr val="FFFFFF"/>
-          </a:solidFill>
-          <a:ln w="12700">
-            <a:solidFill>
-              <a:srgbClr val="DCE3EB"/>
-            </a:solidFill>
-            <a:prstDash val="solid"/>
-          </a:ln>
-          <a:effectLst>
-            <a:outerShdw sx="100000" sy="100000" kx="0" ky="0" algn="bl" rotWithShape="0" blurRad="76200" dist="25400" dir="5400000">
-              <a:srgbClr val="B9C3CE">
-                <a:alpha val="35000"/>
-              </a:srgbClr>
-            </a:outerShdw>
-          </a:effectLst>
-        </p:spPr>
-      </p:sp>
-      <p:sp>
-        <p:nvSpPr>
-          <p:cNvPr id="10" name="Text 8"/>
-          <p:cNvSpPr/>
-          <p:nvPr/>
-        </p:nvSpPr>
-        <p:spPr>
-          <a:xfrm>
-            <a:off x="4572000" y="1874520"/>
-            <a:ext cx="2926080" cy="548640"/>
-          </a:xfrm>
-          <a:prstGeom prst="rect">
-            <a:avLst/>
-          </a:prstGeom>
-          <a:noFill/>
-          <a:ln/>
-        </p:spPr>
-        <p:txBody>
-          <a:bodyPr wrap="square" rtlCol="0" anchor="ctr"/>
-          <a:lstStyle/>
-          <a:p>
-            <a:pPr algn="ctr" indent="0" marL="0">
-              <a:buNone/>
-            </a:pPr>
-            <a:r>
-              <a:rPr lang="en-US" sz="2200" b="1" dirty="0">
-                <a:solidFill>
-                  <a:srgbClr val="24395F"/>
-                </a:solidFill>
-                <a:latin typeface="맑은 고딕" pitchFamily="34" charset="0"/>
-                <a:ea typeface="맑은 고딕" pitchFamily="34" charset="-122"/>
-                <a:cs typeface="맑은 고딕" pitchFamily="34" charset="-120"/>
-              </a:rPr>
-              <a:t>FastAPI</a:t>
-            </a:r>
-            <a:endParaRPr lang="en-US" sz="2200" dirty="0"/>
-          </a:p>
-        </p:txBody>
-      </p:sp>
-      <p:sp>
-        <p:nvSpPr>
-          <p:cNvPr id="11" name="Text 9"/>
-          <p:cNvSpPr/>
-          <p:nvPr/>
-        </p:nvSpPr>
-        <p:spPr>
-          <a:xfrm>
-            <a:off x="4572000" y="2468880"/>
-            <a:ext cx="2926080" cy="457200"/>
-          </a:xfrm>
-          <a:prstGeom prst="rect">
-            <a:avLst/>
-          </a:prstGeom>
-          <a:noFill/>
-          <a:ln/>
-        </p:spPr>
-        <p:txBody>
-          <a:bodyPr wrap="square" rtlCol="0" anchor="ctr"/>
-          <a:lstStyle/>
-          <a:p>
-            <a:pPr algn="ctr" indent="0" marL="0">
-              <a:buNone/>
-            </a:pPr>
-            <a:r>
-              <a:rPr lang="en-US" sz="1400" dirty="0">
-                <a:solidFill>
-                  <a:srgbClr val="63707E"/>
-                </a:solidFill>
-                <a:latin typeface="맑은 고딕" pitchFamily="34" charset="0"/>
-                <a:ea typeface="맑은 고딕" pitchFamily="34" charset="-122"/>
-                <a:cs typeface="맑은 고딕" pitchFamily="34" charset="-120"/>
-              </a:rPr>
-              <a:t>백엔드 (API)</a:t>
-            </a:r>
-            <a:endParaRPr lang="en-US" sz="1400" dirty="0"/>
-          </a:p>
-        </p:txBody>
-      </p:sp>
-      <p:sp>
-        <p:nvSpPr>
-          <p:cNvPr id="12" name="Text 10"/>
-          <p:cNvSpPr/>
-          <p:nvPr/>
-        </p:nvSpPr>
-        <p:spPr>
-          <a:xfrm>
-            <a:off x="7498080" y="1737360"/>
-            <a:ext cx="731520" cy="1371600"/>
-          </a:xfrm>
-          <a:prstGeom prst="rect">
-            <a:avLst/>
-          </a:prstGeom>
-          <a:noFill/>
-          <a:ln/>
-        </p:spPr>
-        <p:txBody>
-          <a:bodyPr wrap="square" rtlCol="0" anchor="ctr"/>
-          <a:lstStyle/>
-          <a:p>
-            <a:pPr algn="ctr" indent="0" marL="0">
-              <a:buNone/>
-            </a:pPr>
-            <a:r>
-              <a:rPr lang="en-US" sz="3000" b="1" dirty="0">
-                <a:solidFill>
-                  <a:srgbClr val="9AA6B2"/>
-                </a:solidFill>
-                <a:latin typeface="맑은 고딕" pitchFamily="34" charset="0"/>
-                <a:ea typeface="맑은 고딕" pitchFamily="34" charset="-122"/>
-                <a:cs typeface="맑은 고딕" pitchFamily="34" charset="-120"/>
-              </a:rPr>
-              <a:t>→</a:t>
-            </a:r>
-            <a:endParaRPr lang="en-US" sz="3000" dirty="0"/>
-          </a:p>
-        </p:txBody>
-      </p:sp>
-      <p:sp>
-        <p:nvSpPr>
-          <p:cNvPr id="13" name="Shape 11"/>
-          <p:cNvSpPr/>
-          <p:nvPr/>
-        </p:nvSpPr>
-        <p:spPr>
-          <a:xfrm>
-            <a:off x="8229600" y="1737360"/>
-            <a:ext cx="2926080" cy="1371600"/>
-          </a:xfrm>
-          <a:prstGeom prst="roundRect">
-            <a:avLst>
-              <a:gd name="adj" fmla="val 5333"/>
-            </a:avLst>
-          </a:prstGeom>
-          <a:solidFill>
-            <a:srgbClr val="FFFFFF"/>
-          </a:solidFill>
-          <a:ln w="12700">
-            <a:solidFill>
-              <a:srgbClr val="DCE3EB"/>
-            </a:solidFill>
-            <a:prstDash val="solid"/>
-          </a:ln>
-          <a:effectLst>
-            <a:outerShdw sx="100000" sy="100000" kx="0" ky="0" algn="bl" rotWithShape="0" blurRad="76200" dist="25400" dir="5400000">
-              <a:srgbClr val="B9C3CE">
-                <a:alpha val="35000"/>
-              </a:srgbClr>
-            </a:outerShdw>
-          </a:effectLst>
-        </p:spPr>
-      </p:sp>
-      <p:sp>
-        <p:nvSpPr>
-          <p:cNvPr id="14" name="Text 12"/>
-          <p:cNvSpPr/>
-          <p:nvPr/>
-        </p:nvSpPr>
-        <p:spPr>
-          <a:xfrm>
-            <a:off x="8229600" y="1874520"/>
-            <a:ext cx="2926080" cy="548640"/>
-          </a:xfrm>
-          <a:prstGeom prst="rect">
-            <a:avLst/>
-          </a:prstGeom>
-          <a:noFill/>
-          <a:ln/>
-        </p:spPr>
-        <p:txBody>
-          <a:bodyPr wrap="square" rtlCol="0" anchor="ctr"/>
-          <a:lstStyle/>
-          <a:p>
-            <a:pPr algn="ctr" indent="0" marL="0">
-              <a:buNone/>
-            </a:pPr>
-            <a:r>
-              <a:rPr lang="en-US" sz="2200" b="1" dirty="0">
-                <a:solidFill>
-                  <a:srgbClr val="C67F17"/>
-                </a:solidFill>
-                <a:latin typeface="맑은 고딕" pitchFamily="34" charset="0"/>
-                <a:ea typeface="맑은 고딕" pitchFamily="34" charset="-122"/>
-                <a:cs typeface="맑은 고딕" pitchFamily="34" charset="-120"/>
-              </a:rPr>
-              <a:t>로컬 LLM</a:t>
-            </a:r>
-            <a:endParaRPr lang="en-US" sz="2200" dirty="0"/>
-          </a:p>
-        </p:txBody>
-      </p:sp>
-      <p:sp>
-        <p:nvSpPr>
-          <p:cNvPr id="15" name="Text 13"/>
-          <p:cNvSpPr/>
-          <p:nvPr/>
-        </p:nvSpPr>
-        <p:spPr>
-          <a:xfrm>
-            <a:off x="8229600" y="2468880"/>
-            <a:ext cx="2926080" cy="457200"/>
-          </a:xfrm>
-          <a:prstGeom prst="rect">
-            <a:avLst/>
-          </a:prstGeom>
-          <a:noFill/>
-          <a:ln/>
-        </p:spPr>
-        <p:txBody>
-          <a:bodyPr wrap="square" rtlCol="0" anchor="ctr"/>
-          <a:lstStyle/>
-          <a:p>
-            <a:pPr algn="ctr" indent="0" marL="0">
-              <a:buNone/>
-            </a:pPr>
-            <a:r>
-              <a:rPr lang="en-US" sz="1400" dirty="0">
-                <a:solidFill>
-                  <a:srgbClr val="63707E"/>
-                </a:solidFill>
-                <a:latin typeface="맑은 고딕" pitchFamily="34" charset="0"/>
-                <a:ea typeface="맑은 고딕" pitchFamily="34" charset="-122"/>
-                <a:cs typeface="맑은 고딕" pitchFamily="34" charset="-120"/>
-              </a:rPr>
-              <a:t>Qwen3-8B (Ollama)</a:t>
-            </a:r>
-            <a:endParaRPr lang="en-US" sz="1400" dirty="0"/>
-          </a:p>
-        </p:txBody>
-      </p:sp>
-      <p:sp>
-        <p:nvSpPr>
-          <p:cNvPr id="16" name="Shape 14"/>
-          <p:cNvSpPr/>
-          <p:nvPr/>
-        </p:nvSpPr>
-        <p:spPr>
-          <a:xfrm>
-            <a:off x="914400" y="3611880"/>
-            <a:ext cx="10332720" cy="1965960"/>
-          </a:xfrm>
-          <a:prstGeom prst="roundRect">
-            <a:avLst>
-              <a:gd name="adj" fmla="val 3721"/>
-            </a:avLst>
-          </a:prstGeom>
-          <a:solidFill>
-            <a:srgbClr val="FFFFFF"/>
-          </a:solidFill>
-          <a:ln w="12700">
-            <a:solidFill>
-              <a:srgbClr val="DCE3EB"/>
-            </a:solidFill>
-            <a:prstDash val="solid"/>
-          </a:ln>
-          <a:effectLst>
-            <a:outerShdw sx="100000" sy="100000" kx="0" ky="0" algn="bl" rotWithShape="0" blurRad="76200" dist="25400" dir="5400000">
-              <a:srgbClr val="B9C3CE">
-                <a:alpha val="35000"/>
-              </a:srgbClr>
-            </a:outerShdw>
-          </a:effectLst>
-        </p:spPr>
-      </p:sp>
-      <p:sp>
-        <p:nvSpPr>
-          <p:cNvPr id="17" name="Text 15"/>
-          <p:cNvSpPr/>
-          <p:nvPr/>
-        </p:nvSpPr>
-        <p:spPr>
-          <a:xfrm>
-            <a:off x="1234440" y="3794760"/>
-            <a:ext cx="9784080" cy="1645920"/>
-          </a:xfrm>
-          <a:prstGeom prst="rect">
-            <a:avLst/>
-          </a:prstGeom>
-          <a:noFill/>
-          <a:ln/>
-        </p:spPr>
-        <p:txBody>
-          <a:bodyPr wrap="square" rtlCol="0" anchor="t"/>
-          <a:lstStyle/>
-          <a:p>
-            <a:pPr marL="177800" indent="-177800">
-              <a:spcAft>
-                <a:spcPts val="900"/>
-              </a:spcAft>
-              <a:buSzPct val="100000"/>
-              <a:buChar char="•"/>
-            </a:pPr>
-            <a:r>
-              <a:rPr lang="en-US" sz="1500" b="1" dirty="0">
-                <a:solidFill>
-                  <a:srgbClr val="1F2733"/>
-                </a:solidFill>
-                <a:latin typeface="맑은 고딕" pitchFamily="34" charset="0"/>
-                <a:ea typeface="맑은 고딕" pitchFamily="34" charset="-122"/>
-                <a:cs typeface="맑은 고딕" pitchFamily="34" charset="-120"/>
-              </a:rPr>
-              <a:t>폐쇄망 + 반출 차단 → 외부 AI(Claude·GPT) 사용 불가 (데이터 반출 금지)</a:t>
-            </a:r>
-            <a:endParaRPr lang="en-US" sz="1500" dirty="0"/>
-          </a:p>
-          <a:p>
-            <a:pPr marL="177800" indent="-177800">
-              <a:spcAft>
-                <a:spcPts val="900"/>
-              </a:spcAft>
-              <a:buSzPct val="100000"/>
-              <a:buChar char="•"/>
-            </a:pPr>
-            <a:r>
-              <a:rPr lang="en-US" sz="1500" dirty="0">
-                <a:solidFill>
-                  <a:srgbClr val="3C4855"/>
-                </a:solidFill>
-                <a:latin typeface="맑은 고딕" pitchFamily="34" charset="0"/>
-                <a:ea typeface="맑은 고딕" pitchFamily="34" charset="-122"/>
-                <a:cs typeface="맑은 고딕" pitchFamily="34" charset="-120"/>
-              </a:rPr>
-              <a:t>→ 사내 워크스테이션에 오픈소스 모델을 로컬 서빙</a:t>
-            </a:r>
-            <a:endParaRPr lang="en-US" sz="1500" dirty="0"/>
-          </a:p>
-          <a:p>
-            <a:pPr marL="177800" indent="-177800">
-              <a:spcAft>
-                <a:spcPts val="900"/>
-              </a:spcAft>
-              <a:buSzPct val="100000"/>
-              <a:buChar char="•"/>
-            </a:pPr>
-            <a:r>
-              <a:rPr lang="en-US" sz="1500" dirty="0">
-                <a:solidFill>
-                  <a:srgbClr val="3C4855"/>
-                </a:solidFill>
-                <a:latin typeface="맑은 고딕" pitchFamily="34" charset="0"/>
-                <a:ea typeface="맑은 고딕" pitchFamily="34" charset="-122"/>
-                <a:cs typeface="맑은 고딕" pitchFamily="34" charset="-120"/>
-              </a:rPr>
-              <a:t>환경: Quadro P4000 (VRAM 8GB) · Xeon 8코어 · RAM 32GB</a:t>
-            </a:r>
-            <a:endParaRPr lang="en-US" sz="1500" dirty="0"/>
-          </a:p>
-          <a:p>
-            <a:pPr marL="177800" indent="-177800">
-              <a:spcAft>
-                <a:spcPts val="900"/>
-              </a:spcAft>
-              <a:buSzPct val="100000"/>
-              <a:buChar char="•"/>
-            </a:pPr>
-            <a:r>
-              <a:rPr lang="en-US" sz="1500" dirty="0">
-                <a:solidFill>
-                  <a:srgbClr val="3C4855"/>
-                </a:solidFill>
-                <a:latin typeface="맑은 고딕" pitchFamily="34" charset="0"/>
-                <a:ea typeface="맑은 고딕" pitchFamily="34" charset="-122"/>
-                <a:cs typeface="맑은 고딕" pitchFamily="34" charset="-120"/>
-              </a:rPr>
-              <a:t>모델: Qwen3-8B (Q5 양자화, GGUF) — 8GB VRAM에 통째로 적재</a:t>
-            </a:r>
-            <a:endParaRPr lang="en-US" sz="1500" dirty="0"/>
+              <a:t>전 구성요소는 사내 폐쇄망 안에서 동작 · AI 추론 상세는 다음 장</a:t>
+            </a:r>
+            <a:endParaRPr lang="en-US" sz="1300" dirty="0"/>
           </a:p>
         </p:txBody>
       </p:sp>
@@ -3680,8 +3838,8 @@
         </p:nvSpPr>
         <p:spPr>
           <a:xfrm>
-            <a:off x="566928" y="182880"/>
-            <a:ext cx="7315200" cy="274320"/>
+            <a:off x="566928" y="201168"/>
+            <a:ext cx="8229600" cy="274320"/>
           </a:xfrm>
           <a:prstGeom prst="rect">
             <a:avLst/>
@@ -3719,8 +3877,8 @@
         </p:nvSpPr>
         <p:spPr>
           <a:xfrm>
-            <a:off x="548640" y="384048"/>
-            <a:ext cx="10424160" cy="640080"/>
+            <a:off x="548640" y="457200"/>
+            <a:ext cx="10424160" cy="658368"/>
           </a:xfrm>
           <a:prstGeom prst="rect">
             <a:avLst/>
@@ -3732,11 +3890,11 @@
           <a:bodyPr wrap="square" rtlCol="0" anchor="ctr"/>
           <a:lstStyle/>
           <a:p>
-            <a:pPr algn="l" indent="0" marL="0">
+            <a:pPr indent="0" marL="0">
               <a:buNone/>
             </a:pPr>
             <a:r>
-              <a:rPr lang="en-US" sz="3000" b="1" dirty="0">
+              <a:rPr lang="en-US" sz="2800" b="1" dirty="0">
                 <a:solidFill>
                   <a:srgbClr val="1B2A4A"/>
                 </a:solidFill>
@@ -3744,9 +3902,9 @@
                 <a:ea typeface="맑은 고딕" pitchFamily="34" charset="-122"/>
                 <a:cs typeface="맑은 고딕" pitchFamily="34" charset="-120"/>
               </a:rPr>
-              <a:t>AI는 어떻게 개발했나</a:t>
-            </a:r>
-            <a:endParaRPr lang="en-US" sz="3000" dirty="0"/>
+              <a:t>AI 추론 — 2가지 (비교)</a:t>
+            </a:r>
+            <a:endParaRPr lang="en-US" sz="2800" dirty="0"/>
           </a:p>
         </p:txBody>
       </p:sp>
@@ -3758,8 +3916,8 @@
         </p:nvSpPr>
         <p:spPr>
           <a:xfrm>
-            <a:off x="11155680" y="384048"/>
-            <a:ext cx="640080" cy="640080"/>
+            <a:off x="11109960" y="457200"/>
+            <a:ext cx="685800" cy="658368"/>
           </a:xfrm>
           <a:prstGeom prst="rect">
             <a:avLst/>
@@ -3775,7 +3933,7 @@
               <a:buNone/>
             </a:pPr>
             <a:r>
-              <a:rPr lang="en-US" sz="2000" b="1" dirty="0">
+              <a:rPr lang="en-US" sz="1900" b="1" dirty="0">
                 <a:solidFill>
                   <a:srgbClr val="C67F17"/>
                 </a:solidFill>
@@ -3785,20 +3943,93 @@
               </a:rPr>
               <a:t>04</a:t>
             </a:r>
-            <a:endParaRPr lang="en-US" sz="2000" dirty="0"/>
-          </a:p>
-        </p:txBody>
-      </p:sp>
-      <p:sp>
-        <p:nvSpPr>
-          <p:cNvPr id="5" name="Text 3"/>
-          <p:cNvSpPr/>
-          <p:nvPr/>
-        </p:nvSpPr>
-        <p:spPr>
-          <a:xfrm>
-            <a:off x="566928" y="1554480"/>
-            <a:ext cx="6675120" cy="3931920"/>
+            <a:endParaRPr lang="en-US" sz="1900" dirty="0"/>
+          </a:p>
+        </p:txBody>
+      </p:sp>
+      <p:sp>
+        <p:nvSpPr>
+          <p:cNvPr id="5" name="Shape 3"/>
+          <p:cNvSpPr/>
+          <p:nvPr/>
+        </p:nvSpPr>
+        <p:spPr>
+          <a:xfrm>
+            <a:off x="566928" y="1371600"/>
+            <a:ext cx="5440680" cy="2697480"/>
+          </a:xfrm>
+          <a:prstGeom prst="roundRect">
+            <a:avLst>
+              <a:gd name="adj" fmla="val 2712"/>
+            </a:avLst>
+          </a:prstGeom>
+          <a:solidFill>
+            <a:srgbClr val="FFFFFF"/>
+          </a:solidFill>
+          <a:ln w="12700">
+            <a:solidFill>
+              <a:srgbClr val="DCE3EB"/>
+            </a:solidFill>
+            <a:prstDash val="solid"/>
+          </a:ln>
+          <a:effectLst>
+            <a:outerShdw sx="100000" sy="100000" kx="0" ky="0" algn="bl" rotWithShape="0" blurRad="76200" dist="25400" dir="5400000">
+              <a:srgbClr val="B9C3CE">
+                <a:alpha val="35000"/>
+              </a:srgbClr>
+            </a:outerShdw>
+          </a:effectLst>
+        </p:spPr>
+      </p:sp>
+      <p:sp>
+        <p:nvSpPr>
+          <p:cNvPr id="6" name="Text 4"/>
+          <p:cNvSpPr/>
+          <p:nvPr/>
+        </p:nvSpPr>
+        <p:spPr>
+          <a:xfrm>
+            <a:off x="822960" y="1572768"/>
+            <a:ext cx="4937760" cy="457200"/>
+          </a:xfrm>
+          <a:prstGeom prst="rect">
+            <a:avLst/>
+          </a:prstGeom>
+          <a:noFill/>
+          <a:ln/>
+        </p:spPr>
+        <p:txBody>
+          <a:bodyPr wrap="square" rtlCol="0" anchor="ctr"/>
+          <a:lstStyle/>
+          <a:p>
+            <a:pPr indent="0" marL="0">
+              <a:buNone/>
+            </a:pPr>
+            <a:r>
+              <a:rPr lang="en-US" sz="1800" b="1" dirty="0">
+                <a:solidFill>
+                  <a:srgbClr val="C67F17"/>
+                </a:solidFill>
+                <a:latin typeface="맑은 고딕" pitchFamily="34" charset="0"/>
+                <a:ea typeface="맑은 고딕" pitchFamily="34" charset="-122"/>
+                <a:cs typeface="맑은 고딕" pitchFamily="34" charset="-120"/>
+              </a:rPr>
+              <a:t>① Qwen3-8B  (주력)</a:t>
+            </a:r>
+            <a:endParaRPr lang="en-US" sz="1800" dirty="0"/>
+          </a:p>
+        </p:txBody>
+      </p:sp>
+      <p:sp>
+        <p:nvSpPr>
+          <p:cNvPr id="7" name="Text 5"/>
+          <p:cNvSpPr/>
+          <p:nvPr/>
+        </p:nvSpPr>
+        <p:spPr>
+          <a:xfrm>
+            <a:off x="868680" y="2103120"/>
+            <a:ext cx="4846320" cy="1828800"/>
           </a:xfrm>
           <a:prstGeom prst="rect">
             <a:avLst/>
@@ -3812,13 +4043,13 @@
           <a:p>
             <a:pPr marL="177800" indent="-177800">
               <a:spcAft>
-                <a:spcPts val="900"/>
+                <a:spcPts val="800"/>
               </a:spcAft>
               <a:buSzPct val="100000"/>
               <a:buChar char="•"/>
             </a:pPr>
             <a:r>
-              <a:rPr lang="en-US" sz="1500" b="1" dirty="0">
+              <a:rPr lang="en-US" sz="1500" dirty="0">
                 <a:solidFill>
                   <a:srgbClr val="1F2733"/>
                 </a:solidFill>
@@ -3826,14 +4057,14 @@
                 <a:ea typeface="맑은 고딕" pitchFamily="34" charset="-122"/>
                 <a:cs typeface="맑은 고딕" pitchFamily="34" charset="-120"/>
               </a:rPr>
-              <a:t>오픈소스 LLM(Qwen3-8B)을 Ollama로 로컬 서빙 — 다운받아 바로 사용</a:t>
+              <a:t>오픈소스 LLM, Ollama로 로컬 서빙</a:t>
             </a:r>
             <a:endParaRPr lang="en-US" sz="1500" dirty="0"/>
           </a:p>
           <a:p>
             <a:pPr marL="177800" indent="-177800">
               <a:spcAft>
-                <a:spcPts val="900"/>
+                <a:spcPts val="800"/>
               </a:spcAft>
               <a:buSzPct val="100000"/>
               <a:buChar char="•"/>
@@ -3847,14 +4078,14 @@
                 <a:ea typeface="맑은 고딕" pitchFamily="34" charset="-122"/>
                 <a:cs typeface="맑은 고딕" pitchFamily="34" charset="-120"/>
               </a:rPr>
-              <a:t>학습(파인튜닝) 없이 프롬프트 기반으로 구현</a:t>
+              <a:t>워크스테이션 GPU(P4000 8GB)에서 구동</a:t>
             </a:r>
             <a:endParaRPr lang="en-US" sz="1500" dirty="0"/>
           </a:p>
           <a:p>
             <a:pPr marL="177800" indent="-177800">
               <a:spcAft>
-                <a:spcPts val="900"/>
+                <a:spcPts val="800"/>
               </a:spcAft>
               <a:buSzPct val="100000"/>
               <a:buChar char="•"/>
@@ -3868,14 +4099,109 @@
                 <a:ea typeface="맑은 고딕" pitchFamily="34" charset="-122"/>
                 <a:cs typeface="맑은 고딕" pitchFamily="34" charset="-120"/>
               </a:rPr>
-              <a:t>프롬프트에 모호성 유형 분류 + 도메인 용어집(AMR·LOAD·UNLOAD 등) 반영</a:t>
+              <a:t>다운받아 바로 사용 · 반출 없음</a:t>
             </a:r>
             <a:endParaRPr lang="en-US" sz="1500" dirty="0"/>
           </a:p>
+        </p:txBody>
+      </p:sp>
+      <p:sp>
+        <p:nvSpPr>
+          <p:cNvPr id="8" name="Shape 6"/>
+          <p:cNvSpPr/>
+          <p:nvPr/>
+        </p:nvSpPr>
+        <p:spPr>
+          <a:xfrm>
+            <a:off x="6199632" y="1371600"/>
+            <a:ext cx="5440680" cy="2697480"/>
+          </a:xfrm>
+          <a:prstGeom prst="roundRect">
+            <a:avLst>
+              <a:gd name="adj" fmla="val 2712"/>
+            </a:avLst>
+          </a:prstGeom>
+          <a:solidFill>
+            <a:srgbClr val="FDF7EE"/>
+          </a:solidFill>
+          <a:ln w="12700">
+            <a:solidFill>
+              <a:srgbClr val="DCE3EB"/>
+            </a:solidFill>
+            <a:prstDash val="solid"/>
+          </a:ln>
+          <a:effectLst>
+            <a:outerShdw sx="100000" sy="100000" kx="0" ky="0" algn="bl" rotWithShape="0" blurRad="76200" dist="25400" dir="5400000">
+              <a:srgbClr val="B9C3CE">
+                <a:alpha val="35000"/>
+              </a:srgbClr>
+            </a:outerShdw>
+          </a:effectLst>
+        </p:spPr>
+      </p:sp>
+      <p:sp>
+        <p:nvSpPr>
+          <p:cNvPr id="9" name="Text 7"/>
+          <p:cNvSpPr/>
+          <p:nvPr/>
+        </p:nvSpPr>
+        <p:spPr>
+          <a:xfrm>
+            <a:off x="6446520" y="1572768"/>
+            <a:ext cx="4937760" cy="457200"/>
+          </a:xfrm>
+          <a:prstGeom prst="rect">
+            <a:avLst/>
+          </a:prstGeom>
+          <a:noFill/>
+          <a:ln/>
+        </p:spPr>
+        <p:txBody>
+          <a:bodyPr wrap="square" rtlCol="0" anchor="ctr"/>
+          <a:lstStyle/>
+          <a:p>
+            <a:pPr indent="0" marL="0">
+              <a:buNone/>
+            </a:pPr>
+            <a:r>
+              <a:rPr lang="en-US" sz="1800" b="1" dirty="0">
+                <a:solidFill>
+                  <a:srgbClr val="2C7A8C"/>
+                </a:solidFill>
+                <a:latin typeface="맑은 고딕" pitchFamily="34" charset="0"/>
+                <a:ea typeface="맑은 고딕" pitchFamily="34" charset="-122"/>
+                <a:cs typeface="맑은 고딕" pitchFamily="34" charset="-120"/>
+              </a:rPr>
+              <a:t>② 사내 playground  (비교용)</a:t>
+            </a:r>
+            <a:endParaRPr lang="en-US" sz="1800" dirty="0"/>
+          </a:p>
+        </p:txBody>
+      </p:sp>
+      <p:sp>
+        <p:nvSpPr>
+          <p:cNvPr id="10" name="Text 8"/>
+          <p:cNvSpPr/>
+          <p:nvPr/>
+        </p:nvSpPr>
+        <p:spPr>
+          <a:xfrm>
+            <a:off x="6492240" y="2103120"/>
+            <a:ext cx="4846320" cy="1828800"/>
+          </a:xfrm>
+          <a:prstGeom prst="rect">
+            <a:avLst/>
+          </a:prstGeom>
+          <a:noFill/>
+          <a:ln/>
+        </p:spPr>
+        <p:txBody>
+          <a:bodyPr wrap="square" rtlCol="0" anchor="t"/>
+          <a:lstStyle/>
           <a:p>
             <a:pPr marL="177800" indent="-177800">
               <a:spcAft>
-                <a:spcPts val="900"/>
+                <a:spcPts val="800"/>
               </a:spcAft>
               <a:buSzPct val="100000"/>
               <a:buChar char="•"/>
@@ -3889,14 +4215,14 @@
                 <a:ea typeface="맑은 고딕" pitchFamily="34" charset="-122"/>
                 <a:cs typeface="맑은 고딕" pitchFamily="34" charset="-120"/>
               </a:rPr>
-              <a:t>모호 조항에 '이렇게 쓰라'는 재작성 예시(suggestion)까지 출력</a:t>
+              <a:t>사내 AI를 API로 호출</a:t>
             </a:r>
             <a:endParaRPr lang="en-US" sz="1500" dirty="0"/>
           </a:p>
           <a:p>
             <a:pPr marL="177800" indent="-177800">
               <a:spcAft>
-                <a:spcPts val="900"/>
+                <a:spcPts val="800"/>
               </a:spcAft>
               <a:buSzPct val="100000"/>
               <a:buChar char="•"/>
@@ -3910,26 +4236,184 @@
                 <a:ea typeface="맑은 고딕" pitchFamily="34" charset="-122"/>
                 <a:cs typeface="맑은 고딕" pitchFamily="34" charset="-120"/>
               </a:rPr>
-              <a:t>결과는 항상 '초안' — 담당자가 검토·수정하는 원칙</a:t>
+              <a:t>사내 서비스라 반출 문제 없음</a:t>
             </a:r>
             <a:endParaRPr lang="en-US" sz="1500" dirty="0"/>
           </a:p>
-        </p:txBody>
-      </p:sp>
-      <p:sp>
-        <p:nvSpPr>
-          <p:cNvPr id="6" name="Shape 4"/>
-          <p:cNvSpPr/>
-          <p:nvPr/>
-        </p:nvSpPr>
-        <p:spPr>
-          <a:xfrm>
-            <a:off x="7589520" y="1737360"/>
-            <a:ext cx="4023360" cy="3200400"/>
+          <a:p>
+            <a:pPr marL="177800" indent="-177800">
+              <a:spcAft>
+                <a:spcPts val="800"/>
+              </a:spcAft>
+              <a:buSzPct val="100000"/>
+              <a:buChar char="•"/>
+            </a:pPr>
+            <a:r>
+              <a:rPr lang="en-US" sz="1500" dirty="0">
+                <a:solidFill>
+                  <a:srgbClr val="1F2733"/>
+                </a:solidFill>
+                <a:latin typeface="맑은 고딕" pitchFamily="34" charset="0"/>
+                <a:ea typeface="맑은 고딕" pitchFamily="34" charset="-122"/>
+                <a:cs typeface="맑은 고딕" pitchFamily="34" charset="-120"/>
+              </a:rPr>
+              <a:t>Qwen3-8B와 정확도·속도 비교 목적</a:t>
+            </a:r>
+            <a:endParaRPr lang="en-US" sz="1500" dirty="0"/>
+          </a:p>
+        </p:txBody>
+      </p:sp>
+      <p:sp>
+        <p:nvSpPr>
+          <p:cNvPr id="11" name="Shape 9"/>
+          <p:cNvSpPr/>
+          <p:nvPr/>
+        </p:nvSpPr>
+        <p:spPr>
+          <a:xfrm>
+            <a:off x="566928" y="4251960"/>
+            <a:ext cx="7406640" cy="1965960"/>
           </a:xfrm>
           <a:prstGeom prst="roundRect">
             <a:avLst>
-              <a:gd name="adj" fmla="val 2286"/>
+              <a:gd name="adj" fmla="val 3721"/>
+            </a:avLst>
+          </a:prstGeom>
+          <a:solidFill>
+            <a:srgbClr val="FFFFFF"/>
+          </a:solidFill>
+          <a:ln w="12700">
+            <a:solidFill>
+              <a:srgbClr val="DCE3EB"/>
+            </a:solidFill>
+            <a:prstDash val="solid"/>
+          </a:ln>
+          <a:effectLst>
+            <a:outerShdw sx="100000" sy="100000" kx="0" ky="0" algn="bl" rotWithShape="0" blurRad="76200" dist="25400" dir="5400000">
+              <a:srgbClr val="B9C3CE">
+                <a:alpha val="35000"/>
+              </a:srgbClr>
+            </a:outerShdw>
+          </a:effectLst>
+        </p:spPr>
+      </p:sp>
+      <p:sp>
+        <p:nvSpPr>
+          <p:cNvPr id="12" name="Text 10"/>
+          <p:cNvSpPr/>
+          <p:nvPr/>
+        </p:nvSpPr>
+        <p:spPr>
+          <a:xfrm>
+            <a:off x="822960" y="4389120"/>
+            <a:ext cx="4572000" cy="365760"/>
+          </a:xfrm>
+          <a:prstGeom prst="rect">
+            <a:avLst/>
+          </a:prstGeom>
+          <a:noFill/>
+          <a:ln/>
+        </p:spPr>
+        <p:txBody>
+          <a:bodyPr wrap="square" rtlCol="0" anchor="ctr"/>
+          <a:lstStyle/>
+          <a:p>
+            <a:pPr indent="0" marL="0">
+              <a:buNone/>
+            </a:pPr>
+            <a:r>
+              <a:rPr lang="en-US" sz="1500" b="1" dirty="0">
+                <a:solidFill>
+                  <a:srgbClr val="24395F"/>
+                </a:solidFill>
+                <a:latin typeface="맑은 고딕" pitchFamily="34" charset="0"/>
+                <a:ea typeface="맑은 고딕" pitchFamily="34" charset="-122"/>
+                <a:cs typeface="맑은 고딕" pitchFamily="34" charset="-120"/>
+              </a:rPr>
+              <a:t>개발 방법</a:t>
+            </a:r>
+            <a:endParaRPr lang="en-US" sz="1500" dirty="0"/>
+          </a:p>
+        </p:txBody>
+      </p:sp>
+      <p:sp>
+        <p:nvSpPr>
+          <p:cNvPr id="13" name="Text 11"/>
+          <p:cNvSpPr/>
+          <p:nvPr/>
+        </p:nvSpPr>
+        <p:spPr>
+          <a:xfrm>
+            <a:off x="868680" y="4800600"/>
+            <a:ext cx="6858000" cy="1280160"/>
+          </a:xfrm>
+          <a:prstGeom prst="rect">
+            <a:avLst/>
+          </a:prstGeom>
+          <a:noFill/>
+          <a:ln/>
+        </p:spPr>
+        <p:txBody>
+          <a:bodyPr wrap="square" rtlCol="0" anchor="t"/>
+          <a:lstStyle/>
+          <a:p>
+            <a:pPr marL="177800" indent="-177800">
+              <a:spcAft>
+                <a:spcPts val="800"/>
+              </a:spcAft>
+              <a:buSzPct val="100000"/>
+              <a:buChar char="•"/>
+            </a:pPr>
+            <a:r>
+              <a:rPr lang="en-US" sz="1500" dirty="0">
+                <a:solidFill>
+                  <a:srgbClr val="1F2733"/>
+                </a:solidFill>
+                <a:latin typeface="맑은 고딕" pitchFamily="34" charset="0"/>
+                <a:ea typeface="맑은 고딕" pitchFamily="34" charset="-122"/>
+                <a:cs typeface="맑은 고딕" pitchFamily="34" charset="-120"/>
+              </a:rPr>
+              <a:t>학습(파인튜닝) 없이 프롬프트 기반</a:t>
+            </a:r>
+            <a:endParaRPr lang="en-US" sz="1500" dirty="0"/>
+          </a:p>
+          <a:p>
+            <a:pPr marL="177800" indent="-177800">
+              <a:spcAft>
+                <a:spcPts val="800"/>
+              </a:spcAft>
+              <a:buSzPct val="100000"/>
+              <a:buChar char="•"/>
+            </a:pPr>
+            <a:r>
+              <a:rPr lang="en-US" sz="1500" dirty="0">
+                <a:solidFill>
+                  <a:srgbClr val="1F2733"/>
+                </a:solidFill>
+                <a:latin typeface="맑은 고딕" pitchFamily="34" charset="0"/>
+                <a:ea typeface="맑은 고딕" pitchFamily="34" charset="-122"/>
+                <a:cs typeface="맑은 고딕" pitchFamily="34" charset="-120"/>
+              </a:rPr>
+              <a:t>프롬프트에 도메인 용어집(AMR·LOAD·UNLOAD 등) + '이렇게 쓰라' 재작성 예시 반영</a:t>
+            </a:r>
+            <a:endParaRPr lang="en-US" sz="1500" dirty="0"/>
+          </a:p>
+        </p:txBody>
+      </p:sp>
+      <p:sp>
+        <p:nvSpPr>
+          <p:cNvPr id="14" name="Shape 12"/>
+          <p:cNvSpPr/>
+          <p:nvPr/>
+        </p:nvSpPr>
+        <p:spPr>
+          <a:xfrm>
+            <a:off x="8138160" y="4251960"/>
+            <a:ext cx="3493008" cy="1965960"/>
+          </a:xfrm>
+          <a:prstGeom prst="roundRect">
+            <a:avLst>
+              <a:gd name="adj" fmla="val 3721"/>
             </a:avLst>
           </a:prstGeom>
           <a:solidFill>
@@ -3952,14 +4436,14 @@
       </p:sp>
       <p:sp>
         <p:nvSpPr>
-          <p:cNvPr id="7" name="Text 5"/>
-          <p:cNvSpPr/>
-          <p:nvPr/>
-        </p:nvSpPr>
-        <p:spPr>
-          <a:xfrm>
-            <a:off x="7589520" y="2057400"/>
-            <a:ext cx="4023360" cy="457200"/>
+          <p:cNvPr id="15" name="Text 13"/>
+          <p:cNvSpPr/>
+          <p:nvPr/>
+        </p:nvSpPr>
+        <p:spPr>
+          <a:xfrm>
+            <a:off x="8138160" y="4434840"/>
+            <a:ext cx="3493008" cy="365760"/>
           </a:xfrm>
           <a:prstGeom prst="rect">
             <a:avLst/>
@@ -3975,7 +4459,7 @@
               <a:buNone/>
             </a:pPr>
             <a:r>
-              <a:rPr lang="en-US" sz="1700" dirty="0">
+              <a:rPr lang="en-US" sz="1500" dirty="0">
                 <a:solidFill>
                   <a:srgbClr val="CADCFC"/>
                 </a:solidFill>
@@ -3985,20 +4469,20 @@
               </a:rPr>
               <a:t>추론 시간</a:t>
             </a:r>
-            <a:endParaRPr lang="en-US" sz="1700" dirty="0"/>
-          </a:p>
-        </p:txBody>
-      </p:sp>
-      <p:sp>
-        <p:nvSpPr>
-          <p:cNvPr id="8" name="Text 6"/>
-          <p:cNvSpPr/>
-          <p:nvPr/>
-        </p:nvSpPr>
-        <p:spPr>
-          <a:xfrm>
-            <a:off x="7589520" y="2560320"/>
-            <a:ext cx="4023360" cy="1097280"/>
+            <a:endParaRPr lang="en-US" sz="1500" dirty="0"/>
+          </a:p>
+        </p:txBody>
+      </p:sp>
+      <p:sp>
+        <p:nvSpPr>
+          <p:cNvPr id="16" name="Text 14"/>
+          <p:cNvSpPr/>
+          <p:nvPr/>
+        </p:nvSpPr>
+        <p:spPr>
+          <a:xfrm>
+            <a:off x="8138160" y="4754880"/>
+            <a:ext cx="3493008" cy="822960"/>
           </a:xfrm>
           <a:prstGeom prst="rect">
             <a:avLst/>
@@ -4014,7 +4498,7 @@
               <a:buNone/>
             </a:pPr>
             <a:r>
-              <a:rPr lang="en-US" sz="5200" b="1" dirty="0">
+              <a:rPr lang="en-US" sz="4000" b="1" dirty="0">
                 <a:solidFill>
                   <a:srgbClr val="FFFFFF"/>
                 </a:solidFill>
@@ -4024,20 +4508,20 @@
               </a:rPr>
               <a:t>약 2~3초</a:t>
             </a:r>
-            <a:endParaRPr lang="en-US" sz="5200" dirty="0"/>
-          </a:p>
-        </p:txBody>
-      </p:sp>
-      <p:sp>
-        <p:nvSpPr>
-          <p:cNvPr id="9" name="Text 7"/>
-          <p:cNvSpPr/>
-          <p:nvPr/>
-        </p:nvSpPr>
-        <p:spPr>
-          <a:xfrm>
-            <a:off x="7589520" y="3703320"/>
-            <a:ext cx="4023360" cy="457200"/>
+            <a:endParaRPr lang="en-US" sz="4000" dirty="0"/>
+          </a:p>
+        </p:txBody>
+      </p:sp>
+      <p:sp>
+        <p:nvSpPr>
+          <p:cNvPr id="17" name="Text 15"/>
+          <p:cNvSpPr/>
+          <p:nvPr/>
+        </p:nvSpPr>
+        <p:spPr>
+          <a:xfrm>
+            <a:off x="8138160" y="5623560"/>
+            <a:ext cx="3493008" cy="365760"/>
           </a:xfrm>
           <a:prstGeom prst="rect">
             <a:avLst/>
@@ -4053,7 +4537,7 @@
               <a:buNone/>
             </a:pPr>
             <a:r>
-              <a:rPr lang="en-US" sz="1500" dirty="0">
+              <a:rPr lang="en-US" sz="1300" dirty="0">
                 <a:solidFill>
                   <a:srgbClr val="AEBFDA"/>
                 </a:solidFill>
@@ -4063,46 +4547,7 @@
               </a:rPr>
               <a:t>기능(조항) 1건당</a:t>
             </a:r>
-            <a:endParaRPr lang="en-US" sz="1500" dirty="0"/>
-          </a:p>
-        </p:txBody>
-      </p:sp>
-      <p:sp>
-        <p:nvSpPr>
-          <p:cNvPr id="10" name="Text 8"/>
-          <p:cNvSpPr/>
-          <p:nvPr/>
-        </p:nvSpPr>
-        <p:spPr>
-          <a:xfrm>
-            <a:off x="7589520" y="4206240"/>
-            <a:ext cx="4023360" cy="640080"/>
-          </a:xfrm>
-          <a:prstGeom prst="rect">
-            <a:avLst/>
-          </a:prstGeom>
-          <a:noFill/>
-          <a:ln/>
-        </p:spPr>
-        <p:txBody>
-          <a:bodyPr wrap="square" rtlCol="0" anchor="ctr"/>
-          <a:lstStyle/>
-          <a:p>
-            <a:pPr algn="ctr" indent="0" marL="0">
-              <a:buNone/>
-            </a:pPr>
-            <a:r>
-              <a:rPr lang="en-US" sz="1200" i="1" dirty="0">
-                <a:solidFill>
-                  <a:srgbClr val="8FA3C6"/>
-                </a:solidFill>
-                <a:latin typeface="맑은 고딕" pitchFamily="34" charset="0"/>
-                <a:ea typeface="맑은 고딕" pitchFamily="34" charset="-122"/>
-                <a:cs typeface="맑은 고딕" pitchFamily="34" charset="-120"/>
-              </a:rPr>
-              <a:t>* 첫 호출은 모델 적재(콜드로드)로 더 걸림 — 이후 정상</a:t>
-            </a:r>
-            <a:endParaRPr lang="en-US" sz="1200" dirty="0"/>
+            <a:endParaRPr lang="en-US" sz="1300" dirty="0"/>
           </a:p>
         </p:txBody>
       </p:sp>
@@ -4146,8 +4591,8 @@
         </p:nvSpPr>
         <p:spPr>
           <a:xfrm>
-            <a:off x="566928" y="182880"/>
-            <a:ext cx="7315200" cy="274320"/>
+            <a:off x="566928" y="201168"/>
+            <a:ext cx="8229600" cy="274320"/>
           </a:xfrm>
           <a:prstGeom prst="rect">
             <a:avLst/>
@@ -4171,7 +4616,7 @@
                 <a:ea typeface="맑은 고딕" pitchFamily="34" charset="-122"/>
                 <a:cs typeface="맑은 고딕" pitchFamily="34" charset="-120"/>
               </a:rPr>
-              <a:t>핵심기능 ① · 데모</a:t>
+              <a:t>핵심기능 ① · 프로세스</a:t>
             </a:r>
             <a:endParaRPr lang="en-US" sz="1200" dirty="0"/>
           </a:p>
@@ -4185,8 +4630,8 @@
         </p:nvSpPr>
         <p:spPr>
           <a:xfrm>
-            <a:off x="548640" y="384048"/>
-            <a:ext cx="10424160" cy="640080"/>
+            <a:off x="548640" y="457200"/>
+            <a:ext cx="10424160" cy="658368"/>
           </a:xfrm>
           <a:prstGeom prst="rect">
             <a:avLst/>
@@ -4198,11 +4643,11 @@
           <a:bodyPr wrap="square" rtlCol="0" anchor="ctr"/>
           <a:lstStyle/>
           <a:p>
-            <a:pPr algn="l" indent="0" marL="0">
+            <a:pPr indent="0" marL="0">
               <a:buNone/>
             </a:pPr>
             <a:r>
-              <a:rPr lang="en-US" sz="3000" b="1" dirty="0">
+              <a:rPr lang="en-US" sz="2800" b="1" dirty="0">
                 <a:solidFill>
                   <a:srgbClr val="1B2A4A"/>
                 </a:solidFill>
@@ -4210,9 +4655,9 @@
                 <a:ea typeface="맑은 고딕" pitchFamily="34" charset="-122"/>
                 <a:cs typeface="맑은 고딕" pitchFamily="34" charset="-120"/>
               </a:rPr>
-              <a:t>모호성 해결 — 이렇게 구현·테스트했다</a:t>
-            </a:r>
-            <a:endParaRPr lang="en-US" sz="3000" dirty="0"/>
+              <a:t>모호성 해결 — docx 업로드부터 해결까지 (하나의 프로세스)</a:t>
+            </a:r>
+            <a:endParaRPr lang="en-US" sz="2800" dirty="0"/>
           </a:p>
         </p:txBody>
       </p:sp>
@@ -4224,8 +4669,8 @@
         </p:nvSpPr>
         <p:spPr>
           <a:xfrm>
-            <a:off x="11155680" y="384048"/>
-            <a:ext cx="640080" cy="640080"/>
+            <a:off x="11109960" y="457200"/>
+            <a:ext cx="685800" cy="658368"/>
           </a:xfrm>
           <a:prstGeom prst="rect">
             <a:avLst/>
@@ -4241,7 +4686,7 @@
               <a:buNone/>
             </a:pPr>
             <a:r>
-              <a:rPr lang="en-US" sz="2000" b="1" dirty="0">
+              <a:rPr lang="en-US" sz="1900" b="1" dirty="0">
                 <a:solidFill>
                   <a:srgbClr val="C67F17"/>
                 </a:solidFill>
@@ -4251,13 +4696,13 @@
               </a:rPr>
               <a:t>05</a:t>
             </a:r>
-            <a:endParaRPr lang="en-US" sz="2000" dirty="0"/>
+            <a:endParaRPr lang="en-US" sz="1900" dirty="0"/>
           </a:p>
         </p:txBody>
       </p:sp>
       <p:pic>
         <p:nvPicPr>
-          <p:cNvPr id="5" name="Image 0" descr="/home/user/semes-superrookie/docs/img/demo-ambiguity-react.png">    </p:cNvPr>
+          <p:cNvPr id="5" name="Image 0" descr="/home/user/semes-superrookie/docs/img/design-fig1.png">    </p:cNvPr>
           <p:cNvPicPr>
             <a:picLocks noChangeAspect="1"/>
           </p:cNvPicPr>
@@ -4265,13 +4710,14 @@
         </p:nvPicPr>
         <p:blipFill>
           <a:blip r:embed="rId1"/>
-          <a:srcRect l="0" r="0" t="0" b="0"/>
-          <a:stretch/>
+          <a:stretch>
+            <a:fillRect/>
+          </a:stretch>
         </p:blipFill>
         <p:spPr>
           <a:xfrm>
-            <a:off x="7471289" y="1234440"/>
-            <a:ext cx="4076943" cy="5120640"/>
+            <a:off x="1393597" y="1280160"/>
+            <a:ext cx="9420045" cy="4160520"/>
           </a:xfrm>
           <a:prstGeom prst="rect">
             <a:avLst/>
@@ -4286,162 +4732,8 @@
         </p:nvSpPr>
         <p:spPr>
           <a:xfrm>
-            <a:off x="566928" y="1554480"/>
-            <a:ext cx="6126480" cy="3657600"/>
-          </a:xfrm>
-          <a:prstGeom prst="rect">
-            <a:avLst/>
-          </a:prstGeom>
-          <a:noFill/>
-          <a:ln/>
-        </p:spPr>
-        <p:txBody>
-          <a:bodyPr wrap="square" rtlCol="0" anchor="t"/>
-          <a:lstStyle/>
-          <a:p>
-            <a:pPr marL="177800" indent="-177800">
-              <a:spcAft>
-                <a:spcPts val="900"/>
-              </a:spcAft>
-              <a:buSzPct val="100000"/>
-              <a:buChar char="•"/>
-            </a:pPr>
-            <a:r>
-              <a:rPr lang="en-US" sz="1500" b="1" dirty="0">
-                <a:solidFill>
-                  <a:srgbClr val="C67F17"/>
-                </a:solidFill>
-                <a:latin typeface="맑은 고딕" pitchFamily="34" charset="0"/>
-                <a:ea typeface="맑은 고딕" pitchFamily="34" charset="-122"/>
-                <a:cs typeface="맑은 고딕" pitchFamily="34" charset="-120"/>
-              </a:rPr>
-              <a:t>요구사항 입력 → 조항별 모호성 검출</a:t>
-            </a:r>
-            <a:endParaRPr lang="en-US" sz="1500" dirty="0"/>
-          </a:p>
-          <a:p>
-            <a:pPr marL="177800" indent="-177800">
-              <a:spcAft>
-                <a:spcPts val="1200"/>
-              </a:spcAft>
-              <a:buSzPct val="100000"/>
-              <a:buChar char="•"/>
-            </a:pPr>
-            <a:r>
-              <a:rPr lang="en-US" sz="1500" dirty="0">
-                <a:solidFill>
-                  <a:srgbClr val="1F2733"/>
-                </a:solidFill>
-                <a:latin typeface="맑은 고딕" pitchFamily="34" charset="0"/>
-                <a:ea typeface="맑은 고딕" pitchFamily="34" charset="-122"/>
-                <a:cs typeface="맑은 고딕" pitchFamily="34" charset="-120"/>
-              </a:rPr>
-              <a:t>유형 · 사유 · 재작성 예시까지 표시</a:t>
-            </a:r>
-            <a:endParaRPr lang="en-US" sz="1500" dirty="0"/>
-          </a:p>
-          <a:p>
-            <a:pPr marL="177800" indent="-177800">
-              <a:spcAft>
-                <a:spcPts val="900"/>
-              </a:spcAft>
-              <a:buSzPct val="100000"/>
-              <a:buChar char="•"/>
-            </a:pPr>
-            <a:r>
-              <a:rPr lang="en-US" sz="1500" b="1" dirty="0">
-                <a:solidFill>
-                  <a:srgbClr val="C67F17"/>
-                </a:solidFill>
-                <a:latin typeface="맑은 고딕" pitchFamily="34" charset="0"/>
-                <a:ea typeface="맑은 고딕" pitchFamily="34" charset="-122"/>
-                <a:cs typeface="맑은 고딕" pitchFamily="34" charset="-120"/>
-              </a:rPr>
-              <a:t>해결하기 / 넘어가기 선택</a:t>
-            </a:r>
-            <a:endParaRPr lang="en-US" sz="1500" dirty="0"/>
-          </a:p>
-          <a:p>
-            <a:pPr marL="177800" indent="-177800">
-              <a:spcAft>
-                <a:spcPts val="1200"/>
-              </a:spcAft>
-              <a:buSzPct val="100000"/>
-              <a:buChar char="•"/>
-            </a:pPr>
-            <a:r>
-              <a:rPr lang="en-US" sz="1500" dirty="0">
-                <a:solidFill>
-                  <a:srgbClr val="1F2733"/>
-                </a:solidFill>
-                <a:latin typeface="맑은 고딕" pitchFamily="34" charset="0"/>
-                <a:ea typeface="맑은 고딕" pitchFamily="34" charset="-122"/>
-                <a:cs typeface="맑은 고딕" pitchFamily="34" charset="-120"/>
-              </a:rPr>
-              <a:t>확정 시 '해결 전 / 후' 비교로 전환</a:t>
-            </a:r>
-            <a:endParaRPr lang="en-US" sz="1500" dirty="0"/>
-          </a:p>
-          <a:p>
-            <a:pPr marL="177800" indent="-177800">
-              <a:spcAft>
-                <a:spcPts val="900"/>
-              </a:spcAft>
-              <a:buSzPct val="100000"/>
-              <a:buChar char="•"/>
-            </a:pPr>
-            <a:r>
-              <a:rPr lang="en-US" sz="1500" dirty="0">
-                <a:solidFill>
-                  <a:srgbClr val="3C4855"/>
-                </a:solidFill>
-                <a:latin typeface="맑은 고딕" pitchFamily="34" charset="0"/>
-                <a:ea typeface="맑은 고딕" pitchFamily="34" charset="-122"/>
-                <a:cs typeface="맑은 고딕" pitchFamily="34" charset="-120"/>
-              </a:rPr>
-              <a:t>React + FastAPI + 로컬 LLM로 실제 동작</a:t>
-            </a:r>
-            <a:endParaRPr lang="en-US" sz="1500" dirty="0"/>
-          </a:p>
-        </p:txBody>
-      </p:sp>
-      <p:sp>
-        <p:nvSpPr>
-          <p:cNvPr id="7" name="Shape 4"/>
-          <p:cNvSpPr/>
-          <p:nvPr/>
-        </p:nvSpPr>
-        <p:spPr>
-          <a:xfrm>
-            <a:off x="566928" y="5074920"/>
-            <a:ext cx="2743200" cy="502920"/>
-          </a:xfrm>
-          <a:prstGeom prst="roundRect">
-            <a:avLst>
-              <a:gd name="adj" fmla="val 18182"/>
-            </a:avLst>
-          </a:prstGeom>
-          <a:solidFill>
-            <a:srgbClr val="DDF0E4"/>
-          </a:solidFill>
-          <a:ln w="12700">
-            <a:solidFill>
-              <a:srgbClr val="2A8A57"/>
-            </a:solidFill>
-            <a:prstDash val="solid"/>
-          </a:ln>
-        </p:spPr>
-      </p:sp>
-      <p:sp>
-        <p:nvSpPr>
-          <p:cNvPr id="8" name="Text 5"/>
-          <p:cNvSpPr/>
-          <p:nvPr/>
-        </p:nvSpPr>
-        <p:spPr>
-          <a:xfrm>
-            <a:off x="566928" y="5074920"/>
-            <a:ext cx="2743200" cy="502920"/>
+            <a:off x="566928" y="5943600"/>
+            <a:ext cx="11064240" cy="457200"/>
           </a:xfrm>
           <a:prstGeom prst="rect">
             <a:avLst/>
@@ -4457,17 +4749,17 @@
               <a:buNone/>
             </a:pPr>
             <a:r>
-              <a:rPr lang="en-US" sz="1500" b="1" dirty="0">
-                <a:solidFill>
-                  <a:srgbClr val="2A8A57"/>
-                </a:solidFill>
-                <a:latin typeface="맑은 고딕" pitchFamily="34" charset="0"/>
-                <a:ea typeface="맑은 고딕" pitchFamily="34" charset="-122"/>
-                <a:cs typeface="맑은 고딕" pitchFamily="34" charset="-120"/>
-              </a:rPr>
-              <a:t>✔  테스트 완료</a:t>
-            </a:r>
-            <a:endParaRPr lang="en-US" sz="1500" dirty="0"/>
+              <a:rPr lang="en-US" sz="1350" b="1" dirty="0">
+                <a:solidFill>
+                  <a:srgbClr val="24395F"/>
+                </a:solidFill>
+                <a:latin typeface="맑은 고딕" pitchFamily="34" charset="0"/>
+                <a:ea typeface="맑은 고딕" pitchFamily="34" charset="-122"/>
+                <a:cs typeface="맑은 고딕" pitchFamily="34" charset="-120"/>
+              </a:rPr>
+              <a:t>① docx 업로드·파싱  →  ② 조항별 모호성 검출(유형·근거·재작성 예시)  →  ③ 해결(해석 입력)/넘어가기  →  ④ 해결 전·후 비교</a:t>
+            </a:r>
+            <a:endParaRPr lang="en-US" sz="1350" dirty="0"/>
           </a:p>
         </p:txBody>
       </p:sp>
@@ -4511,8 +4803,8 @@
         </p:nvSpPr>
         <p:spPr>
           <a:xfrm>
-            <a:off x="566928" y="182880"/>
-            <a:ext cx="7315200" cy="274320"/>
+            <a:off x="566928" y="201168"/>
+            <a:ext cx="8229600" cy="274320"/>
           </a:xfrm>
           <a:prstGeom prst="rect">
             <a:avLst/>
@@ -4536,7 +4828,7 @@
                 <a:ea typeface="맑은 고딕" pitchFamily="34" charset="-122"/>
                 <a:cs typeface="맑은 고딕" pitchFamily="34" charset="-120"/>
               </a:rPr>
-              <a:t>테스트</a:t>
+              <a:t>핵심기능 ① · 구현/테스트</a:t>
             </a:r>
             <a:endParaRPr lang="en-US" sz="1200" dirty="0"/>
           </a:p>
@@ -4550,8 +4842,8 @@
         </p:nvSpPr>
         <p:spPr>
           <a:xfrm>
-            <a:off x="548640" y="384048"/>
-            <a:ext cx="10424160" cy="640080"/>
+            <a:off x="548640" y="457200"/>
+            <a:ext cx="10424160" cy="658368"/>
           </a:xfrm>
           <a:prstGeom prst="rect">
             <a:avLst/>
@@ -4563,11 +4855,11 @@
           <a:bodyPr wrap="square" rtlCol="0" anchor="ctr"/>
           <a:lstStyle/>
           <a:p>
-            <a:pPr algn="l" indent="0" marL="0">
+            <a:pPr indent="0" marL="0">
               <a:buNone/>
             </a:pPr>
             <a:r>
-              <a:rPr lang="en-US" sz="3000" b="1" dirty="0">
+              <a:rPr lang="en-US" sz="2800" b="1" dirty="0">
                 <a:solidFill>
                   <a:srgbClr val="1B2A4A"/>
                 </a:solidFill>
@@ -4575,9 +4867,9 @@
                 <a:ea typeface="맑은 고딕" pitchFamily="34" charset="-122"/>
                 <a:cs typeface="맑은 고딕" pitchFamily="34" charset="-120"/>
               </a:rPr>
-              <a:t>docx 업로드 · 파싱 테스트</a:t>
-            </a:r>
-            <a:endParaRPr lang="en-US" sz="3000" dirty="0"/>
+              <a:t>실제로 이렇게 구현·테스트했다</a:t>
+            </a:r>
+            <a:endParaRPr lang="en-US" sz="2800" dirty="0"/>
           </a:p>
         </p:txBody>
       </p:sp>
@@ -4589,8 +4881,8 @@
         </p:nvSpPr>
         <p:spPr>
           <a:xfrm>
-            <a:off x="11155680" y="384048"/>
-            <a:ext cx="640080" cy="640080"/>
+            <a:off x="11109960" y="457200"/>
+            <a:ext cx="685800" cy="658368"/>
           </a:xfrm>
           <a:prstGeom prst="rect">
             <a:avLst/>
@@ -4606,7 +4898,7 @@
               <a:buNone/>
             </a:pPr>
             <a:r>
-              <a:rPr lang="en-US" sz="2000" b="1" dirty="0">
+              <a:rPr lang="en-US" sz="1900" b="1" dirty="0">
                 <a:solidFill>
                   <a:srgbClr val="C67F17"/>
                 </a:solidFill>
@@ -4616,13 +4908,13 @@
               </a:rPr>
               <a:t>06</a:t>
             </a:r>
-            <a:endParaRPr lang="en-US" sz="2000" dirty="0"/>
+            <a:endParaRPr lang="en-US" sz="1900" dirty="0"/>
           </a:p>
         </p:txBody>
       </p:sp>
       <p:pic>
         <p:nvPicPr>
-          <p:cNvPr id="5" name="Image 0" descr="/home/user/semes-superrookie/docs/img/demo-docx-upload.png">    </p:cNvPr>
+          <p:cNvPr id="5" name="Image 0" descr="/home/user/semes-superrookie/docs/img/demo-ambiguity-react.png">    </p:cNvPr>
           <p:cNvPicPr>
             <a:picLocks noChangeAspect="1"/>
           </p:cNvPicPr>
@@ -4630,13 +4922,14 @@
         </p:nvPicPr>
         <p:blipFill>
           <a:blip r:embed="rId1"/>
-          <a:srcRect l="0" r="0" t="0" b="0"/>
-          <a:stretch/>
+          <a:stretch>
+            <a:fillRect/>
+          </a:stretch>
         </p:blipFill>
         <p:spPr>
           <a:xfrm>
-            <a:off x="6949440" y="1371600"/>
-            <a:ext cx="4754880" cy="4754880"/>
+            <a:off x="7443769" y="1280160"/>
+            <a:ext cx="4040541" cy="5074920"/>
           </a:xfrm>
           <a:prstGeom prst="rect">
             <a:avLst/>
@@ -4651,8 +4944,8 @@
         </p:nvSpPr>
         <p:spPr>
           <a:xfrm>
-            <a:off x="566928" y="1554480"/>
-            <a:ext cx="6126480" cy="3474720"/>
+            <a:off x="566928" y="1508760"/>
+            <a:ext cx="6217920" cy="3200400"/>
           </a:xfrm>
           <a:prstGeom prst="rect">
             <a:avLst/>
@@ -4666,7 +4959,7 @@
           <a:p>
             <a:pPr marL="177800" indent="-177800">
               <a:spcAft>
-                <a:spcPts val="900"/>
+                <a:spcPts val="800"/>
               </a:spcAft>
               <a:buSzPct val="100000"/>
               <a:buChar char="•"/>
@@ -4674,20 +4967,20 @@
             <a:r>
               <a:rPr lang="en-US" sz="1500" b="1" dirty="0">
                 <a:solidFill>
-                  <a:srgbClr val="2C7A8C"/>
-                </a:solidFill>
-                <a:latin typeface="맑은 고딕" pitchFamily="34" charset="0"/>
-                <a:ea typeface="맑은 고딕" pitchFamily="34" charset="-122"/>
-                <a:cs typeface="맑은 고딕" pitchFamily="34" charset="-120"/>
-              </a:rPr>
-              <a:t>명세서 파일을 웹에 업로드</a:t>
+                  <a:srgbClr val="C67F17"/>
+                </a:solidFill>
+                <a:latin typeface="맑은 고딕" pitchFamily="34" charset="0"/>
+                <a:ea typeface="맑은 고딕" pitchFamily="34" charset="-122"/>
+                <a:cs typeface="맑은 고딕" pitchFamily="34" charset="-120"/>
+              </a:rPr>
+              <a:t>docx 업로드 → 문단·표 파싱 (같은 프로세스의 앞단)</a:t>
             </a:r>
             <a:endParaRPr lang="en-US" sz="1500" dirty="0"/>
           </a:p>
           <a:p>
             <a:pPr marL="177800" indent="-177800">
               <a:spcAft>
-                <a:spcPts val="1200"/>
+                <a:spcPts val="1100"/>
               </a:spcAft>
               <a:buSzPct val="100000"/>
               <a:buChar char="•"/>
@@ -4701,35 +4994,35 @@
                 <a:ea typeface="맑은 고딕" pitchFamily="34" charset="-122"/>
                 <a:cs typeface="맑은 고딕" pitchFamily="34" charset="-120"/>
               </a:rPr>
-              <a:t>문단 · 표를 파싱해 그대로 표시</a:t>
+              <a:t>조항별로 모호 유형·근거·재작성 예시 표시</a:t>
             </a:r>
             <a:endParaRPr lang="en-US" sz="1500" dirty="0"/>
           </a:p>
           <a:p>
             <a:pPr marL="177800" indent="-177800">
               <a:spcAft>
-                <a:spcPts val="900"/>
+                <a:spcPts val="800"/>
               </a:spcAft>
               <a:buSzPct val="100000"/>
               <a:buChar char="•"/>
             </a:pPr>
             <a:r>
-              <a:rPr lang="en-US" sz="1500" dirty="0">
-                <a:solidFill>
-                  <a:srgbClr val="1F2733"/>
-                </a:solidFill>
-                <a:latin typeface="맑은 고딕" pitchFamily="34" charset="0"/>
-                <a:ea typeface="맑은 고딕" pitchFamily="34" charset="-122"/>
-                <a:cs typeface="맑은 고딕" pitchFamily="34" charset="-120"/>
-              </a:rPr>
-              <a:t>정상 docx는 파싱 성공 확인</a:t>
+              <a:rPr lang="en-US" sz="1500" b="1" dirty="0">
+                <a:solidFill>
+                  <a:srgbClr val="C67F17"/>
+                </a:solidFill>
+                <a:latin typeface="맑은 고딕" pitchFamily="34" charset="0"/>
+                <a:ea typeface="맑은 고딕" pitchFamily="34" charset="-122"/>
+                <a:cs typeface="맑은 고딕" pitchFamily="34" charset="-120"/>
+              </a:rPr>
+              <a:t>해결하기(해석 입력) / 넘어가기 선택</a:t>
             </a:r>
             <a:endParaRPr lang="en-US" sz="1500" dirty="0"/>
           </a:p>
           <a:p>
             <a:pPr marL="177800" indent="-177800">
               <a:spcAft>
-                <a:spcPts val="900"/>
+                <a:spcPts val="1100"/>
               </a:spcAft>
               <a:buSzPct val="100000"/>
               <a:buChar char="•"/>
@@ -4737,13 +5030,34 @@
             <a:r>
               <a:rPr lang="en-US" sz="1500" dirty="0">
                 <a:solidFill>
+                  <a:srgbClr val="1F2733"/>
+                </a:solidFill>
+                <a:latin typeface="맑은 고딕" pitchFamily="34" charset="0"/>
+                <a:ea typeface="맑은 고딕" pitchFamily="34" charset="-122"/>
+                <a:cs typeface="맑은 고딕" pitchFamily="34" charset="-120"/>
+              </a:rPr>
+              <a:t>확정 시 '해결 전 / 후' 비교로 전환</a:t>
+            </a:r>
+            <a:endParaRPr lang="en-US" sz="1500" dirty="0"/>
+          </a:p>
+          <a:p>
+            <a:pPr marL="177800" indent="-177800">
+              <a:spcAft>
+                <a:spcPts val="800"/>
+              </a:spcAft>
+              <a:buSzPct val="100000"/>
+              <a:buChar char="•"/>
+            </a:pPr>
+            <a:r>
+              <a:rPr lang="en-US" sz="1500" dirty="0">
+                <a:solidFill>
                   <a:srgbClr val="3C4855"/>
                 </a:solidFill>
                 <a:latin typeface="맑은 고딕" pitchFamily="34" charset="0"/>
                 <a:ea typeface="맑은 고딕" pitchFamily="34" charset="-122"/>
                 <a:cs typeface="맑은 고딕" pitchFamily="34" charset="-120"/>
               </a:rPr>
-              <a:t>실제 명세서가 조항 단위로 잘 쪼개지는지 확인용</a:t>
+              <a:t>React + FastAPI + 로컬 LLM으로 실제 동작</a:t>
             </a:r>
             <a:endParaRPr lang="en-US" sz="1500" dirty="0"/>
           </a:p>
@@ -4757,12 +5071,12 @@
         </p:nvSpPr>
         <p:spPr>
           <a:xfrm>
-            <a:off x="566928" y="5074920"/>
-            <a:ext cx="2743200" cy="502920"/>
+            <a:off x="566928" y="4892040"/>
+            <a:ext cx="2651760" cy="475488"/>
           </a:xfrm>
           <a:prstGeom prst="roundRect">
             <a:avLst>
-              <a:gd name="adj" fmla="val 18182"/>
+              <a:gd name="adj" fmla="val 19231"/>
             </a:avLst>
           </a:prstGeom>
           <a:solidFill>
@@ -4784,8 +5098,8 @@
         </p:nvSpPr>
         <p:spPr>
           <a:xfrm>
-            <a:off x="566928" y="5074920"/>
-            <a:ext cx="2743200" cy="502920"/>
+            <a:off x="566928" y="4892040"/>
+            <a:ext cx="2651760" cy="475488"/>
           </a:xfrm>
           <a:prstGeom prst="rect">
             <a:avLst/>
@@ -4801,7 +5115,7 @@
               <a:buNone/>
             </a:pPr>
             <a:r>
-              <a:rPr lang="en-US" sz="1500" b="1" dirty="0">
+              <a:rPr lang="en-US" sz="1400" b="1" dirty="0">
                 <a:solidFill>
                   <a:srgbClr val="2A8A57"/>
                 </a:solidFill>
@@ -4811,7 +5125,70 @@
               </a:rPr>
               <a:t>✔  테스트 완료</a:t>
             </a:r>
-            <a:endParaRPr lang="en-US" sz="1500" dirty="0"/>
+            <a:endParaRPr lang="en-US" sz="1400" dirty="0"/>
+          </a:p>
+        </p:txBody>
+      </p:sp>
+      <p:pic>
+        <p:nvPicPr>
+          <p:cNvPr id="9" name="Image 1" descr="/home/user/semes-superrookie/docs/img/demo-docx-upload.png">    </p:cNvPr>
+          <p:cNvPicPr>
+            <a:picLocks noChangeAspect="1"/>
+          </p:cNvPicPr>
+          <p:nvPr/>
+        </p:nvPicPr>
+        <p:blipFill>
+          <a:blip r:embed="rId2"/>
+          <a:stretch>
+            <a:fillRect/>
+          </a:stretch>
+        </p:blipFill>
+        <p:spPr>
+          <a:xfrm>
+            <a:off x="566928" y="5440680"/>
+            <a:ext cx="1005840" cy="1005840"/>
+          </a:xfrm>
+          <a:prstGeom prst="rect">
+            <a:avLst/>
+          </a:prstGeom>
+        </p:spPr>
+      </p:pic>
+      <p:sp>
+        <p:nvSpPr>
+          <p:cNvPr id="10" name="Text 6"/>
+          <p:cNvSpPr/>
+          <p:nvPr/>
+        </p:nvSpPr>
+        <p:spPr>
+          <a:xfrm>
+            <a:off x="1737360" y="5715000"/>
+            <a:ext cx="4114800" cy="365760"/>
+          </a:xfrm>
+          <a:prstGeom prst="rect">
+            <a:avLst/>
+          </a:prstGeom>
+          <a:noFill/>
+          <a:ln/>
+        </p:spPr>
+        <p:txBody>
+          <a:bodyPr wrap="square" rtlCol="0" anchor="ctr"/>
+          <a:lstStyle/>
+          <a:p>
+            <a:pPr indent="0" marL="0">
+              <a:buNone/>
+            </a:pPr>
+            <a:r>
+              <a:rPr lang="en-US" sz="1200" i="1" dirty="0">
+                <a:solidFill>
+                  <a:srgbClr val="63707E"/>
+                </a:solidFill>
+                <a:latin typeface="맑은 고딕" pitchFamily="34" charset="0"/>
+                <a:ea typeface="맑은 고딕" pitchFamily="34" charset="-122"/>
+                <a:cs typeface="맑은 고딕" pitchFamily="34" charset="-120"/>
+              </a:rPr>
+              <a:t>docx 업로드·파싱 화면</a:t>
+            </a:r>
+            <a:endParaRPr lang="en-US" sz="1200" dirty="0"/>
           </a:p>
         </p:txBody>
       </p:sp>
@@ -4855,8 +5232,8 @@
         </p:nvSpPr>
         <p:spPr>
           <a:xfrm>
-            <a:off x="566928" y="182880"/>
-            <a:ext cx="7315200" cy="274320"/>
+            <a:off x="566928" y="201168"/>
+            <a:ext cx="8229600" cy="274320"/>
           </a:xfrm>
           <a:prstGeom prst="rect">
             <a:avLst/>
@@ -4880,7 +5257,7 @@
                 <a:ea typeface="맑은 고딕" pitchFamily="34" charset="-122"/>
                 <a:cs typeface="맑은 고딕" pitchFamily="34" charset="-120"/>
               </a:rPr>
-              <a:t>핵심기능 ③ · 설계</a:t>
+              <a:t>핵심기능 ② · 설계</a:t>
             </a:r>
             <a:endParaRPr lang="en-US" sz="1200" dirty="0"/>
           </a:p>
@@ -4894,8 +5271,8 @@
         </p:nvSpPr>
         <p:spPr>
           <a:xfrm>
-            <a:off x="548640" y="384048"/>
-            <a:ext cx="10424160" cy="640080"/>
+            <a:off x="548640" y="457200"/>
+            <a:ext cx="10424160" cy="658368"/>
           </a:xfrm>
           <a:prstGeom prst="rect">
             <a:avLst/>
@@ -4907,11 +5284,11 @@
           <a:bodyPr wrap="square" rtlCol="0" anchor="ctr"/>
           <a:lstStyle/>
           <a:p>
-            <a:pPr algn="l" indent="0" marL="0">
+            <a:pPr indent="0" marL="0">
               <a:buNone/>
             </a:pPr>
             <a:r>
-              <a:rPr lang="en-US" sz="3000" b="1" dirty="0">
+              <a:rPr lang="en-US" sz="2800" b="1" dirty="0">
                 <a:solidFill>
                   <a:srgbClr val="1B2A4A"/>
                 </a:solidFill>
@@ -4919,9 +5296,9 @@
                 <a:ea typeface="맑은 고딕" pitchFamily="34" charset="-122"/>
                 <a:cs typeface="맑은 고딕" pitchFamily="34" charset="-120"/>
               </a:rPr>
-              <a:t>DB 변경 관리 · 알림</a:t>
-            </a:r>
-            <a:endParaRPr lang="en-US" sz="3000" dirty="0"/>
+              <a:t>기능 요구사항 도출 — 하나의 기능 → UI·APP 명세</a:t>
+            </a:r>
+            <a:endParaRPr lang="en-US" sz="2800" dirty="0"/>
           </a:p>
         </p:txBody>
       </p:sp>
@@ -4933,8 +5310,8 @@
         </p:nvSpPr>
         <p:spPr>
           <a:xfrm>
-            <a:off x="11155680" y="384048"/>
-            <a:ext cx="640080" cy="640080"/>
+            <a:off x="11109960" y="457200"/>
+            <a:ext cx="685800" cy="658368"/>
           </a:xfrm>
           <a:prstGeom prst="rect">
             <a:avLst/>
@@ -4950,7 +5327,7 @@
               <a:buNone/>
             </a:pPr>
             <a:r>
-              <a:rPr lang="en-US" sz="2000" b="1" dirty="0">
+              <a:rPr lang="en-US" sz="1900" b="1" dirty="0">
                 <a:solidFill>
                   <a:srgbClr val="C67F17"/>
                 </a:solidFill>
@@ -4960,20 +5337,44 @@
               </a:rPr>
               <a:t>07</a:t>
             </a:r>
-            <a:endParaRPr lang="en-US" sz="2000" dirty="0"/>
-          </a:p>
-        </p:txBody>
-      </p:sp>
-      <p:sp>
-        <p:nvSpPr>
-          <p:cNvPr id="5" name="Text 3"/>
-          <p:cNvSpPr/>
-          <p:nvPr/>
-        </p:nvSpPr>
-        <p:spPr>
-          <a:xfrm>
-            <a:off x="566928" y="1417320"/>
-            <a:ext cx="10972800" cy="1554480"/>
+            <a:endParaRPr lang="en-US" sz="1900" dirty="0"/>
+          </a:p>
+        </p:txBody>
+      </p:sp>
+      <p:pic>
+        <p:nvPicPr>
+          <p:cNvPr id="5" name="Image 0" descr="/home/user/semes-superrookie/docs/img/design-fig2.png">    </p:cNvPr>
+          <p:cNvPicPr>
+            <a:picLocks noChangeAspect="1"/>
+          </p:cNvPicPr>
+          <p:nvPr/>
+        </p:nvPicPr>
+        <p:blipFill>
+          <a:blip r:embed="rId1"/>
+          <a:stretch>
+            <a:fillRect/>
+          </a:stretch>
+        </p:blipFill>
+        <p:spPr>
+          <a:xfrm>
+            <a:off x="1064481" y="1234440"/>
+            <a:ext cx="10078278" cy="3566160"/>
+          </a:xfrm>
+          <a:prstGeom prst="rect">
+            <a:avLst/>
+          </a:prstGeom>
+        </p:spPr>
+      </p:pic>
+      <p:sp>
+        <p:nvSpPr>
+          <p:cNvPr id="6" name="Text 3"/>
+          <p:cNvSpPr/>
+          <p:nvPr/>
+        </p:nvSpPr>
+        <p:spPr>
+          <a:xfrm>
+            <a:off x="640080" y="5029200"/>
+            <a:ext cx="10972800" cy="1280160"/>
           </a:xfrm>
           <a:prstGeom prst="rect">
             <a:avLst/>
@@ -4987,7 +5388,7 @@
           <a:p>
             <a:pPr marL="177800" indent="-177800">
               <a:spcAft>
-                <a:spcPts val="900"/>
+                <a:spcPts val="800"/>
               </a:spcAft>
               <a:buSzPct val="100000"/>
               <a:buChar char="•"/>
@@ -5001,14 +5402,14 @@
                 <a:ea typeface="맑은 고딕" pitchFamily="34" charset="-122"/>
                 <a:cs typeface="맑은 고딕" pitchFamily="34" charset="-120"/>
               </a:rPr>
-              <a:t>담당자가 DB 변경(테이블·컬럼·권한)을 등록</a:t>
+              <a:t>확정 요구사항 → 개발 단위 '기능(FEAT)'으로 분해</a:t>
             </a:r>
             <a:endParaRPr lang="en-US" sz="1500" dirty="0"/>
           </a:p>
           <a:p>
             <a:pPr marL="177800" indent="-177800">
               <a:spcAft>
-                <a:spcPts val="900"/>
+                <a:spcPts val="800"/>
               </a:spcAft>
               <a:buSzPct val="100000"/>
               <a:buChar char="•"/>
@@ -5022,14 +5423,14 @@
                 <a:ea typeface="맑은 고딕" pitchFamily="34" charset="-122"/>
                 <a:cs typeface="맑은 고딕" pitchFamily="34" charset="-120"/>
               </a:rPr>
-              <a:t>→ 팀원에게 알림 → 모두가 최신 스키마 공유</a:t>
+              <a:t>AI가 UI / APP(backend) 구분 → 하나의 기능에서 여러 UI·APP 기능명세 파생</a:t>
             </a:r>
             <a:endParaRPr lang="en-US" sz="1500" dirty="0"/>
           </a:p>
           <a:p>
             <a:pPr marL="177800" indent="-177800">
               <a:spcAft>
-                <a:spcPts val="900"/>
+                <a:spcPts val="800"/>
               </a:spcAft>
               <a:buSzPct val="100000"/>
               <a:buChar char="•"/>
@@ -5043,56 +5444,12 @@
                 <a:ea typeface="맑은 고딕" pitchFamily="34" charset="-122"/>
                 <a:cs typeface="맑은 고딕" pitchFamily="34" charset="-120"/>
               </a:rPr>
-              <a:t>'각자 다른 스키마로 인한 누락' 문제 해결</a:t>
+              <a:t>APP은 8개 모듈별로 관리(NATS 메시지), 상세에서 통신방식·subject·입출력 편집 가능</a:t>
             </a:r>
             <a:endParaRPr lang="en-US" sz="1500" dirty="0"/>
           </a:p>
-          <a:p>
-            <a:pPr marL="177800" indent="-177800">
-              <a:spcAft>
-                <a:spcPts val="900"/>
-              </a:spcAft>
-              <a:buSzPct val="100000"/>
-              <a:buChar char="•"/>
-            </a:pPr>
-            <a:r>
-              <a:rPr lang="en-US" sz="1500" b="1" dirty="0">
-                <a:solidFill>
-                  <a:srgbClr val="63707E"/>
-                </a:solidFill>
-                <a:latin typeface="맑은 고딕" pitchFamily="34" charset="0"/>
-                <a:ea typeface="맑은 고딕" pitchFamily="34" charset="-122"/>
-                <a:cs typeface="맑은 고딕" pitchFamily="34" charset="-120"/>
-              </a:rPr>
-              <a:t>테스트는 불필요해 미실시 — 화면/설계안 단계</a:t>
-            </a:r>
-            <a:endParaRPr lang="en-US" sz="1500" dirty="0"/>
-          </a:p>
-        </p:txBody>
-      </p:sp>
-      <p:pic>
-        <p:nvPicPr>
-          <p:cNvPr id="6" name="Image 0" descr="/home/user/semes-superrookie/docs/img/design-fig3.png">    </p:cNvPr>
-          <p:cNvPicPr>
-            <a:picLocks noChangeAspect="1"/>
-          </p:cNvPicPr>
-          <p:nvPr/>
-        </p:nvPicPr>
-        <p:blipFill>
-          <a:blip r:embed="rId1"/>
-          <a:srcRect l="0" r="0" t="0" b="0"/>
-          <a:stretch/>
-        </p:blipFill>
-        <p:spPr>
-          <a:xfrm>
-            <a:off x="1113609" y="2880360"/>
-            <a:ext cx="9934303" cy="3566160"/>
-          </a:xfrm>
-          <a:prstGeom prst="rect">
-            <a:avLst/>
-          </a:prstGeom>
-        </p:spPr>
-      </p:pic>
+        </p:txBody>
+      </p:sp>
     </p:spTree>
   </p:cSld>
   <p:clrMapOvr>
@@ -5133,8 +5490,8 @@
         </p:nvSpPr>
         <p:spPr>
           <a:xfrm>
-            <a:off x="566928" y="182880"/>
-            <a:ext cx="7315200" cy="274320"/>
+            <a:off x="566928" y="201168"/>
+            <a:ext cx="8229600" cy="274320"/>
           </a:xfrm>
           <a:prstGeom prst="rect">
             <a:avLst/>
@@ -5158,7 +5515,7 @@
                 <a:ea typeface="맑은 고딕" pitchFamily="34" charset="-122"/>
                 <a:cs typeface="맑은 고딕" pitchFamily="34" charset="-120"/>
               </a:rPr>
-              <a:t>FRONTEND</a:t>
+              <a:t>핵심기능 ③ · 설계</a:t>
             </a:r>
             <a:endParaRPr lang="en-US" sz="1200" dirty="0"/>
           </a:p>
@@ -5172,8 +5529,8 @@
         </p:nvSpPr>
         <p:spPr>
           <a:xfrm>
-            <a:off x="548640" y="384048"/>
-            <a:ext cx="10424160" cy="640080"/>
+            <a:off x="548640" y="457200"/>
+            <a:ext cx="10424160" cy="658368"/>
           </a:xfrm>
           <a:prstGeom prst="rect">
             <a:avLst/>
@@ -5185,11 +5542,11 @@
           <a:bodyPr wrap="square" rtlCol="0" anchor="ctr"/>
           <a:lstStyle/>
           <a:p>
-            <a:pPr algn="l" indent="0" marL="0">
+            <a:pPr indent="0" marL="0">
               <a:buNone/>
             </a:pPr>
             <a:r>
-              <a:rPr lang="en-US" sz="3000" b="1" dirty="0">
+              <a:rPr lang="en-US" sz="2800" b="1" dirty="0">
                 <a:solidFill>
                   <a:srgbClr val="1B2A4A"/>
                 </a:solidFill>
@@ -5197,9 +5554,9 @@
                 <a:ea typeface="맑은 고딕" pitchFamily="34" charset="-122"/>
                 <a:cs typeface="맑은 고딕" pitchFamily="34" charset="-120"/>
               </a:rPr>
-              <a:t>프론트엔드 — React 선택 이유 &amp; 이슈</a:t>
-            </a:r>
-            <a:endParaRPr lang="en-US" sz="3000" dirty="0"/>
+              <a:t>DB 변경 관리 — 최종 → 개인 스키마 동기화(pull)</a:t>
+            </a:r>
+            <a:endParaRPr lang="en-US" sz="2800" dirty="0"/>
           </a:p>
         </p:txBody>
       </p:sp>
@@ -5211,8 +5568,8 @@
         </p:nvSpPr>
         <p:spPr>
           <a:xfrm>
-            <a:off x="11155680" y="384048"/>
-            <a:ext cx="640080" cy="640080"/>
+            <a:off x="11109960" y="457200"/>
+            <a:ext cx="685800" cy="658368"/>
           </a:xfrm>
           <a:prstGeom prst="rect">
             <a:avLst/>
@@ -5228,7 +5585,7 @@
               <a:buNone/>
             </a:pPr>
             <a:r>
-              <a:rPr lang="en-US" sz="2000" b="1" dirty="0">
+              <a:rPr lang="en-US" sz="1900" b="1" dirty="0">
                 <a:solidFill>
                   <a:srgbClr val="C67F17"/>
                 </a:solidFill>
@@ -5238,93 +5595,20 @@
               </a:rPr>
               <a:t>08</a:t>
             </a:r>
-            <a:endParaRPr lang="en-US" sz="2000" dirty="0"/>
-          </a:p>
-        </p:txBody>
-      </p:sp>
-      <p:sp>
-        <p:nvSpPr>
-          <p:cNvPr id="5" name="Shape 3"/>
-          <p:cNvSpPr/>
-          <p:nvPr/>
-        </p:nvSpPr>
-        <p:spPr>
-          <a:xfrm>
-            <a:off x="566928" y="1554480"/>
-            <a:ext cx="5486400" cy="3931920"/>
-          </a:xfrm>
-          <a:prstGeom prst="roundRect">
-            <a:avLst>
-              <a:gd name="adj" fmla="val 1860"/>
-            </a:avLst>
-          </a:prstGeom>
-          <a:solidFill>
-            <a:srgbClr val="FFFFFF"/>
-          </a:solidFill>
-          <a:ln w="12700">
-            <a:solidFill>
-              <a:srgbClr val="DCE3EB"/>
-            </a:solidFill>
-            <a:prstDash val="solid"/>
-          </a:ln>
-          <a:effectLst>
-            <a:outerShdw sx="100000" sy="100000" kx="0" ky="0" algn="bl" rotWithShape="0" blurRad="76200" dist="25400" dir="5400000">
-              <a:srgbClr val="B9C3CE">
-                <a:alpha val="35000"/>
-              </a:srgbClr>
-            </a:outerShdw>
-          </a:effectLst>
-        </p:spPr>
-      </p:sp>
-      <p:sp>
-        <p:nvSpPr>
-          <p:cNvPr id="6" name="Text 4"/>
-          <p:cNvSpPr/>
-          <p:nvPr/>
-        </p:nvSpPr>
-        <p:spPr>
-          <a:xfrm>
-            <a:off x="822960" y="1737360"/>
-            <a:ext cx="5029200" cy="457200"/>
-          </a:xfrm>
-          <a:prstGeom prst="rect">
-            <a:avLst/>
-          </a:prstGeom>
-          <a:noFill/>
-          <a:ln/>
-        </p:spPr>
-        <p:txBody>
-          <a:bodyPr wrap="square" rtlCol="0" anchor="ctr"/>
-          <a:lstStyle/>
-          <a:p>
-            <a:pPr indent="0" marL="0">
-              <a:buNone/>
-            </a:pPr>
-            <a:r>
-              <a:rPr lang="en-US" sz="1900" b="1" dirty="0">
-                <a:solidFill>
-                  <a:srgbClr val="2C7A8C"/>
-                </a:solidFill>
-                <a:latin typeface="맑은 고딕" pitchFamily="34" charset="0"/>
-                <a:ea typeface="맑은 고딕" pitchFamily="34" charset="-122"/>
-                <a:cs typeface="맑은 고딕" pitchFamily="34" charset="-120"/>
-              </a:rPr>
-              <a:t>장점</a:t>
-            </a:r>
             <a:endParaRPr lang="en-US" sz="1900" dirty="0"/>
           </a:p>
         </p:txBody>
       </p:sp>
       <p:sp>
         <p:nvSpPr>
-          <p:cNvPr id="7" name="Text 5"/>
-          <p:cNvSpPr/>
-          <p:nvPr/>
-        </p:nvSpPr>
-        <p:spPr>
-          <a:xfrm>
-            <a:off x="868680" y="2286000"/>
-            <a:ext cx="4937760" cy="2926080"/>
+          <p:cNvPr id="5" name="Text 3"/>
+          <p:cNvSpPr/>
+          <p:nvPr/>
+        </p:nvSpPr>
+        <p:spPr>
+          <a:xfrm>
+            <a:off x="566928" y="1234440"/>
+            <a:ext cx="11064240" cy="1554480"/>
           </a:xfrm>
           <a:prstGeom prst="rect">
             <a:avLst/>
@@ -5338,13 +5622,13 @@
           <a:p>
             <a:pPr marL="177800" indent="-177800">
               <a:spcAft>
-                <a:spcPts val="900"/>
+                <a:spcPts val="800"/>
               </a:spcAft>
               <a:buSzPct val="100000"/>
               <a:buChar char="•"/>
             </a:pPr>
             <a:r>
-              <a:rPr lang="en-US" sz="1500" dirty="0">
+              <a:rPr lang="en-US" sz="1500" b="1" dirty="0">
                 <a:solidFill>
                   <a:srgbClr val="1F2733"/>
                 </a:solidFill>
@@ -5352,14 +5636,14 @@
                 <a:ea typeface="맑은 고딕" pitchFamily="34" charset="-122"/>
                 <a:cs typeface="맑은 고딕" pitchFamily="34" charset="-120"/>
               </a:rPr>
-              <a:t>컴포넌트 기반 → 화면 재사용·유지보수 쉬움</a:t>
+              <a:t>개인 스키마(개발·테스트) vs 최종 스키마(고객 배포 기준) — 모두 최종에 맞춰야 함</a:t>
             </a:r>
             <a:endParaRPr lang="en-US" sz="1500" dirty="0"/>
           </a:p>
           <a:p>
             <a:pPr marL="177800" indent="-177800">
               <a:spcAft>
-                <a:spcPts val="900"/>
+                <a:spcPts val="800"/>
               </a:spcAft>
               <a:buSzPct val="100000"/>
               <a:buChar char="•"/>
@@ -5373,14 +5657,14 @@
                 <a:ea typeface="맑은 고딕" pitchFamily="34" charset="-122"/>
                 <a:cs typeface="맑은 고딕" pitchFamily="34" charset="-120"/>
               </a:rPr>
-              <a:t>상태관리로 검출·해결 상태 즉시 반영 (인터랙티브)</a:t>
+              <a:t>최종이 바뀌면 변경점 감지·알림 → 클릭 한 번으로 내 스키마에 pull (git 모델)</a:t>
             </a:r>
             <a:endParaRPr lang="en-US" sz="1500" dirty="0"/>
           </a:p>
           <a:p>
             <a:pPr marL="177800" indent="-177800">
               <a:spcAft>
-                <a:spcPts val="900"/>
+                <a:spcPts val="800"/>
               </a:spcAft>
               <a:buSzPct val="100000"/>
               <a:buChar char="•"/>
@@ -5388,197 +5672,42 @@
             <a:r>
               <a:rPr lang="en-US" sz="1500" dirty="0">
                 <a:solidFill>
-                  <a:srgbClr val="1F2733"/>
-                </a:solidFill>
-                <a:latin typeface="맑은 고딕" pitchFamily="34" charset="0"/>
-                <a:ea typeface="맑은 고딕" pitchFamily="34" charset="-122"/>
-                <a:cs typeface="맑은 고딕" pitchFamily="34" charset="-120"/>
-              </a:rPr>
-              <a:t>표준·생태계 넓음, 설계서 기술스택과 일치</a:t>
+                  <a:srgbClr val="3C4855"/>
+                </a:solidFill>
+                <a:latin typeface="맑은 고딕" pitchFamily="34" charset="0"/>
+                <a:ea typeface="맑은 고딕" pitchFamily="34" charset="-122"/>
+                <a:cs typeface="맑은 고딕" pitchFamily="34" charset="-120"/>
+              </a:rPr>
+              <a:t>추가(컬럼·행)는 즉시 안전 적용 / 삭제·타입변경은 확인 후 적용 (데이터 손실 방지)</a:t>
             </a:r>
             <a:endParaRPr lang="en-US" sz="1500" dirty="0"/>
           </a:p>
         </p:txBody>
       </p:sp>
-      <p:sp>
-        <p:nvSpPr>
-          <p:cNvPr id="8" name="Shape 6"/>
-          <p:cNvSpPr/>
-          <p:nvPr/>
-        </p:nvSpPr>
-        <p:spPr>
-          <a:xfrm>
-            <a:off x="6309360" y="1554480"/>
-            <a:ext cx="5303520" cy="3931920"/>
-          </a:xfrm>
-          <a:prstGeom prst="roundRect">
-            <a:avLst>
-              <a:gd name="adj" fmla="val 1860"/>
-            </a:avLst>
-          </a:prstGeom>
-          <a:solidFill>
-            <a:srgbClr val="FDF4E7"/>
-          </a:solidFill>
-          <a:ln w="12700">
-            <a:solidFill>
-              <a:srgbClr val="DCE3EB"/>
-            </a:solidFill>
-            <a:prstDash val="solid"/>
-          </a:ln>
-          <a:effectLst>
-            <a:outerShdw sx="100000" sy="100000" kx="0" ky="0" algn="bl" rotWithShape="0" blurRad="76200" dist="25400" dir="5400000">
-              <a:srgbClr val="B9C3CE">
-                <a:alpha val="35000"/>
-              </a:srgbClr>
-            </a:outerShdw>
-          </a:effectLst>
-        </p:spPr>
-      </p:sp>
-      <p:sp>
-        <p:nvSpPr>
-          <p:cNvPr id="9" name="Text 7"/>
-          <p:cNvSpPr/>
-          <p:nvPr/>
-        </p:nvSpPr>
-        <p:spPr>
-          <a:xfrm>
-            <a:off x="6583680" y="1737360"/>
-            <a:ext cx="4846320" cy="457200"/>
-          </a:xfrm>
-          <a:prstGeom prst="rect">
-            <a:avLst/>
-          </a:prstGeom>
-          <a:noFill/>
-          <a:ln/>
-        </p:spPr>
-        <p:txBody>
-          <a:bodyPr wrap="square" rtlCol="0" anchor="ctr"/>
-          <a:lstStyle/>
-          <a:p>
-            <a:pPr indent="0" marL="0">
-              <a:buNone/>
-            </a:pPr>
-            <a:r>
-              <a:rPr lang="en-US" sz="1900" b="1" dirty="0">
-                <a:solidFill>
-                  <a:srgbClr val="C67F17"/>
-                </a:solidFill>
-                <a:latin typeface="맑은 고딕" pitchFamily="34" charset="0"/>
-                <a:ea typeface="맑은 고딕" pitchFamily="34" charset="-122"/>
-                <a:cs typeface="맑은 고딕" pitchFamily="34" charset="-120"/>
-              </a:rPr>
-              <a:t>이슈 (고민)</a:t>
-            </a:r>
-            <a:endParaRPr lang="en-US" sz="1900" dirty="0"/>
-          </a:p>
-        </p:txBody>
-      </p:sp>
-      <p:sp>
-        <p:nvSpPr>
-          <p:cNvPr id="10" name="Text 8"/>
-          <p:cNvSpPr/>
-          <p:nvPr/>
-        </p:nvSpPr>
-        <p:spPr>
-          <a:xfrm>
-            <a:off x="6583680" y="2286000"/>
-            <a:ext cx="4754880" cy="2926080"/>
-          </a:xfrm>
-          <a:prstGeom prst="rect">
-            <a:avLst/>
-          </a:prstGeom>
-          <a:noFill/>
-          <a:ln/>
-        </p:spPr>
-        <p:txBody>
-          <a:bodyPr wrap="square" rtlCol="0" anchor="t"/>
-          <a:lstStyle/>
-          <a:p>
-            <a:pPr marL="177800" indent="-177800">
-              <a:spcAft>
-                <a:spcPts val="900"/>
-              </a:spcAft>
-              <a:buSzPct val="100000"/>
-              <a:buChar char="•"/>
-            </a:pPr>
-            <a:r>
-              <a:rPr lang="en-US" sz="1500" b="1" dirty="0">
-                <a:solidFill>
-                  <a:srgbClr val="1F2733"/>
-                </a:solidFill>
-                <a:latin typeface="맑은 고딕" pitchFamily="34" charset="0"/>
-                <a:ea typeface="맑은 고딕" pitchFamily="34" charset="-122"/>
-                <a:cs typeface="맑은 고딕" pitchFamily="34" charset="-120"/>
-              </a:rPr>
-              <a:t>빌드에 필요한 npm install이 사내 프록시 인증서로 막힘</a:t>
-            </a:r>
-            <a:endParaRPr lang="en-US" sz="1500" dirty="0"/>
-          </a:p>
-          <a:p>
-            <a:pPr marL="177800" indent="-177800">
-              <a:spcAft>
-                <a:spcPts val="900"/>
-              </a:spcAft>
-              <a:buSzPct val="100000"/>
-              <a:buChar char="•"/>
-            </a:pPr>
-            <a:r>
-              <a:rPr lang="en-US" sz="1300" dirty="0">
-                <a:solidFill>
-                  <a:srgbClr val="63707E"/>
-                </a:solidFill>
-                <a:latin typeface="맑은 고딕" pitchFamily="34" charset="0"/>
-                <a:ea typeface="맑은 고딕" pitchFamily="34" charset="-122"/>
-                <a:cs typeface="맑은 고딕" pitchFamily="34" charset="-120"/>
-              </a:rPr>
-              <a:t>( UNABLE_TO_VERIFY_LEAF_SIGNATURE )</a:t>
-            </a:r>
-            <a:endParaRPr lang="en-US" sz="1500" dirty="0"/>
-          </a:p>
-          <a:p>
-            <a:pPr marL="177800" indent="-177800">
-              <a:spcAft>
-                <a:spcPts val="1200"/>
-              </a:spcAft>
-              <a:buSzPct val="100000"/>
-              <a:buChar char="•"/>
-            </a:pPr>
-            <a:r>
-              <a:rPr lang="en-US" sz="1500" dirty="0">
-                <a:solidFill>
-                  <a:srgbClr val="1F2733"/>
-                </a:solidFill>
-                <a:latin typeface="맑은 고딕" pitchFamily="34" charset="0"/>
-                <a:ea typeface="맑은 고딕" pitchFamily="34" charset="-122"/>
-                <a:cs typeface="맑은 고딕" pitchFamily="34" charset="-120"/>
-              </a:rPr>
-              <a:t>보안이라 함부로 설정 변경도 어려움</a:t>
-            </a:r>
-            <a:endParaRPr lang="en-US" sz="1500" dirty="0"/>
-          </a:p>
-          <a:p>
-            <a:pPr marL="177800" indent="-177800">
-              <a:spcAft>
-                <a:spcPts val="900"/>
-              </a:spcAft>
-              <a:buSzPct val="100000"/>
-              <a:buChar char="•"/>
-            </a:pPr>
-            <a:r>
-              <a:rPr lang="en-US" sz="1500" dirty="0">
-                <a:solidFill>
-                  <a:srgbClr val="2A8A57"/>
-                </a:solidFill>
-                <a:latin typeface="맑은 고딕" pitchFamily="34" charset="0"/>
-                <a:ea typeface="맑은 고딕" pitchFamily="34" charset="-122"/>
-                <a:cs typeface="맑은 고딕" pitchFamily="34" charset="-120"/>
-              </a:rPr>
-              <a:t>임시 대응: 미리 빌드한 결과물(dist)만 넣어 실행 → npm 없이 구동</a:t>
-            </a:r>
-            <a:endParaRPr lang="en-US" sz="1500" dirty="0"/>
-          </a:p>
-        </p:txBody>
-      </p:sp>
+      <p:pic>
+        <p:nvPicPr>
+          <p:cNvPr id="6" name="Image 0" descr="/home/user/semes-superrookie/docs/img/design-fig4.png">    </p:cNvPr>
+          <p:cNvPicPr>
+            <a:picLocks noChangeAspect="1"/>
+          </p:cNvPicPr>
+          <p:nvPr/>
+        </p:nvPicPr>
+        <p:blipFill>
+          <a:blip r:embed="rId1"/>
+          <a:stretch>
+            <a:fillRect/>
+          </a:stretch>
+        </p:blipFill>
+        <p:spPr>
+          <a:xfrm>
+            <a:off x="640080" y="2899381"/>
+            <a:ext cx="10927080" cy="3208079"/>
+          </a:xfrm>
+          <a:prstGeom prst="rect">
+            <a:avLst/>
+          </a:prstGeom>
+        </p:spPr>
+      </p:pic>
     </p:spTree>
   </p:cSld>
   <p:clrMapOvr>
@@ -5619,8 +5748,8 @@
         </p:nvSpPr>
         <p:spPr>
           <a:xfrm>
-            <a:off x="566928" y="182880"/>
-            <a:ext cx="7315200" cy="274320"/>
+            <a:off x="566928" y="201168"/>
+            <a:ext cx="8229600" cy="274320"/>
           </a:xfrm>
           <a:prstGeom prst="rect">
             <a:avLst/>
@@ -5644,7 +5773,7 @@
                 <a:ea typeface="맑은 고딕" pitchFamily="34" charset="-122"/>
                 <a:cs typeface="맑은 고딕" pitchFamily="34" charset="-120"/>
               </a:rPr>
-              <a:t>ISSUE</a:t>
+              <a:t>FRONTEND</a:t>
             </a:r>
             <a:endParaRPr lang="en-US" sz="1200" dirty="0"/>
           </a:p>
@@ -5658,8 +5787,8 @@
         </p:nvSpPr>
         <p:spPr>
           <a:xfrm>
-            <a:off x="548640" y="384048"/>
-            <a:ext cx="10424160" cy="640080"/>
+            <a:off x="548640" y="457200"/>
+            <a:ext cx="10424160" cy="658368"/>
           </a:xfrm>
           <a:prstGeom prst="rect">
             <a:avLst/>
@@ -5671,11 +5800,11 @@
           <a:bodyPr wrap="square" rtlCol="0" anchor="ctr"/>
           <a:lstStyle/>
           <a:p>
-            <a:pPr algn="l" indent="0" marL="0">
+            <a:pPr indent="0" marL="0">
               <a:buNone/>
             </a:pPr>
             <a:r>
-              <a:rPr lang="en-US" sz="3000" b="1" dirty="0">
+              <a:rPr lang="en-US" sz="2800" b="1" dirty="0">
                 <a:solidFill>
                   <a:srgbClr val="1B2A4A"/>
                 </a:solidFill>
@@ -5683,9 +5812,9 @@
                 <a:ea typeface="맑은 고딕" pitchFamily="34" charset="-122"/>
                 <a:cs typeface="맑은 고딕" pitchFamily="34" charset="-120"/>
               </a:rPr>
-              <a:t>발견된 이슈 &amp; 해결 방향</a:t>
-            </a:r>
-            <a:endParaRPr lang="en-US" sz="3000" dirty="0"/>
+              <a:t>프론트엔드 — React 선택 이유 &amp; 이슈</a:t>
+            </a:r>
+            <a:endParaRPr lang="en-US" sz="2800" dirty="0"/>
           </a:p>
         </p:txBody>
       </p:sp>
@@ -5697,8 +5826,8 @@
         </p:nvSpPr>
         <p:spPr>
           <a:xfrm>
-            <a:off x="11155680" y="384048"/>
-            <a:ext cx="640080" cy="640080"/>
+            <a:off x="11109960" y="457200"/>
+            <a:ext cx="685800" cy="658368"/>
           </a:xfrm>
           <a:prstGeom prst="rect">
             <a:avLst/>
@@ -5714,7 +5843,7 @@
               <a:buNone/>
             </a:pPr>
             <a:r>
-              <a:rPr lang="en-US" sz="2000" b="1" dirty="0">
+              <a:rPr lang="en-US" sz="1900" b="1" dirty="0">
                 <a:solidFill>
                   <a:srgbClr val="C67F17"/>
                 </a:solidFill>
@@ -5724,7 +5853,7 @@
               </a:rPr>
               <a:t>09</a:t>
             </a:r>
-            <a:endParaRPr lang="en-US" sz="2000" dirty="0"/>
+            <a:endParaRPr lang="en-US" sz="1900" dirty="0"/>
           </a:p>
         </p:txBody>
       </p:sp>
@@ -5737,148 +5866,11 @@
         <p:spPr>
           <a:xfrm>
             <a:off x="566928" y="1463040"/>
-            <a:ext cx="11064240" cy="1828800"/>
+            <a:ext cx="5486400" cy="4114800"/>
           </a:xfrm>
           <a:prstGeom prst="roundRect">
             <a:avLst>
-              <a:gd name="adj" fmla="val 4000"/>
-            </a:avLst>
-          </a:prstGeom>
-          <a:solidFill>
-            <a:srgbClr val="FBEDEC"/>
-          </a:solidFill>
-          <a:ln w="12700">
-            <a:solidFill>
-              <a:srgbClr val="DCE3EB"/>
-            </a:solidFill>
-            <a:prstDash val="solid"/>
-          </a:ln>
-          <a:effectLst>
-            <a:outerShdw sx="100000" sy="100000" kx="0" ky="0" algn="bl" rotWithShape="0" blurRad="76200" dist="25400" dir="5400000">
-              <a:srgbClr val="B9C3CE">
-                <a:alpha val="35000"/>
-              </a:srgbClr>
-            </a:outerShdw>
-          </a:effectLst>
-        </p:spPr>
-      </p:sp>
-      <p:sp>
-        <p:nvSpPr>
-          <p:cNvPr id="6" name="Text 4"/>
-          <p:cNvSpPr/>
-          <p:nvPr/>
-        </p:nvSpPr>
-        <p:spPr>
-          <a:xfrm>
-            <a:off x="868680" y="1645920"/>
-            <a:ext cx="10515600" cy="457200"/>
-          </a:xfrm>
-          <a:prstGeom prst="rect">
-            <a:avLst/>
-          </a:prstGeom>
-          <a:noFill/>
-          <a:ln/>
-        </p:spPr>
-        <p:txBody>
-          <a:bodyPr wrap="square" rtlCol="0" anchor="ctr"/>
-          <a:lstStyle/>
-          <a:p>
-            <a:pPr indent="0" marL="0">
-              <a:buNone/>
-            </a:pPr>
-            <a:r>
-              <a:rPr lang="en-US" sz="1800" b="1" dirty="0">
-                <a:solidFill>
-                  <a:srgbClr val="C0503F"/>
-                </a:solidFill>
-                <a:latin typeface="맑은 고딕" pitchFamily="34" charset="0"/>
-                <a:ea typeface="맑은 고딕" pitchFamily="34" charset="-122"/>
-                <a:cs typeface="맑은 고딕" pitchFamily="34" charset="-120"/>
-              </a:rPr>
-              <a:t>★  실제 명세서 docx 파싱 실패  —  "file is not a zip file"</a:t>
-            </a:r>
-            <a:endParaRPr lang="en-US" sz="1800" dirty="0"/>
-          </a:p>
-        </p:txBody>
-      </p:sp>
-      <p:sp>
-        <p:nvSpPr>
-          <p:cNvPr id="7" name="Text 5"/>
-          <p:cNvSpPr/>
-          <p:nvPr/>
-        </p:nvSpPr>
-        <p:spPr>
-          <a:xfrm>
-            <a:off x="868680" y="2148840"/>
-            <a:ext cx="10515600" cy="1005840"/>
-          </a:xfrm>
-          <a:prstGeom prst="rect">
-            <a:avLst/>
-          </a:prstGeom>
-          <a:noFill/>
-          <a:ln/>
-        </p:spPr>
-        <p:txBody>
-          <a:bodyPr wrap="square" rtlCol="0" anchor="t"/>
-          <a:lstStyle/>
-          <a:p>
-            <a:pPr marL="177800" indent="-177800">
-              <a:spcAft>
-                <a:spcPts val="900"/>
-              </a:spcAft>
-              <a:buSzPct val="100000"/>
-              <a:buChar char="•"/>
-            </a:pPr>
-            <a:r>
-              <a:rPr lang="en-US" sz="1500" dirty="0">
-                <a:solidFill>
-                  <a:srgbClr val="5A3A36"/>
-                </a:solidFill>
-                <a:latin typeface="맑은 고딕" pitchFamily="34" charset="0"/>
-                <a:ea typeface="맑은 고딕" pitchFamily="34" charset="-122"/>
-                <a:cs typeface="맑은 고딕" pitchFamily="34" charset="-120"/>
-              </a:rPr>
-              <a:t>원인 추정: 문서보안(DRM)·암호 또는 한글(hwp)·구버전(.doc) → raw 파일이 zip 아님 (Word에선 열려도)</a:t>
-            </a:r>
-            <a:endParaRPr lang="en-US" sz="1500" dirty="0"/>
-          </a:p>
-          <a:p>
-            <a:pPr marL="177800" indent="-177800">
-              <a:spcAft>
-                <a:spcPts val="900"/>
-              </a:spcAft>
-              <a:buSzPct val="100000"/>
-              <a:buChar char="•"/>
-            </a:pPr>
-            <a:r>
-              <a:rPr lang="en-US" sz="1500" dirty="0">
-                <a:solidFill>
-                  <a:srgbClr val="2A8A57"/>
-                </a:solidFill>
-                <a:latin typeface="맑은 고딕" pitchFamily="34" charset="0"/>
-                <a:ea typeface="맑은 고딕" pitchFamily="34" charset="-122"/>
-                <a:cs typeface="맑은 고딕" pitchFamily="34" charset="-120"/>
-              </a:rPr>
-              <a:t>해결방향: 실제 파일 시그니처 확인 중 / 보안 해제 사본 테스트 / hwp면 hwp 파싱 지원 검토</a:t>
-            </a:r>
-            <a:endParaRPr lang="en-US" sz="1500" dirty="0"/>
-          </a:p>
-        </p:txBody>
-      </p:sp>
-      <p:sp>
-        <p:nvSpPr>
-          <p:cNvPr id="8" name="Shape 6"/>
-          <p:cNvSpPr/>
-          <p:nvPr/>
-        </p:nvSpPr>
-        <p:spPr>
-          <a:xfrm>
-            <a:off x="566928" y="3474720"/>
-            <a:ext cx="5440680" cy="2103120"/>
-          </a:xfrm>
-          <a:prstGeom prst="roundRect">
-            <a:avLst>
-              <a:gd name="adj" fmla="val 3478"/>
+              <a:gd name="adj" fmla="val 1778"/>
             </a:avLst>
           </a:prstGeom>
           <a:solidFill>
@@ -5901,14 +5893,14 @@
       </p:sp>
       <p:sp>
         <p:nvSpPr>
-          <p:cNvPr id="9" name="Text 7"/>
-          <p:cNvSpPr/>
-          <p:nvPr/>
-        </p:nvSpPr>
-        <p:spPr>
-          <a:xfrm>
-            <a:off x="822960" y="3657600"/>
-            <a:ext cx="4937760" cy="457200"/>
+          <p:cNvPr id="6" name="Text 4"/>
+          <p:cNvSpPr/>
+          <p:nvPr/>
+        </p:nvSpPr>
+        <p:spPr>
+          <a:xfrm>
+            <a:off x="822960" y="1645920"/>
+            <a:ext cx="5029200" cy="457200"/>
           </a:xfrm>
           <a:prstGeom prst="rect">
             <a:avLst/>
@@ -5924,30 +5916,30 @@
               <a:buNone/>
             </a:pPr>
             <a:r>
-              <a:rPr lang="en-US" sz="1700" b="1" dirty="0">
-                <a:solidFill>
-                  <a:srgbClr val="C67F17"/>
-                </a:solidFill>
-                <a:latin typeface="맑은 고딕" pitchFamily="34" charset="0"/>
-                <a:ea typeface="맑은 고딕" pitchFamily="34" charset="-122"/>
-                <a:cs typeface="맑은 고딕" pitchFamily="34" charset="-120"/>
-              </a:rPr>
-              <a:t>모호성 과검출</a:t>
-            </a:r>
-            <a:endParaRPr lang="en-US" sz="1700" dirty="0"/>
-          </a:p>
-        </p:txBody>
-      </p:sp>
-      <p:sp>
-        <p:nvSpPr>
-          <p:cNvPr id="10" name="Text 8"/>
-          <p:cNvSpPr/>
-          <p:nvPr/>
-        </p:nvSpPr>
-        <p:spPr>
-          <a:xfrm>
-            <a:off x="868680" y="4160520"/>
-            <a:ext cx="4846320" cy="1280160"/>
+              <a:rPr lang="en-US" sz="1900" b="1" dirty="0">
+                <a:solidFill>
+                  <a:srgbClr val="2C7A8C"/>
+                </a:solidFill>
+                <a:latin typeface="맑은 고딕" pitchFamily="34" charset="0"/>
+                <a:ea typeface="맑은 고딕" pitchFamily="34" charset="-122"/>
+                <a:cs typeface="맑은 고딕" pitchFamily="34" charset="-120"/>
+              </a:rPr>
+              <a:t>장점</a:t>
+            </a:r>
+            <a:endParaRPr lang="en-US" sz="1900" dirty="0"/>
+          </a:p>
+        </p:txBody>
+      </p:sp>
+      <p:sp>
+        <p:nvSpPr>
+          <p:cNvPr id="7" name="Text 5"/>
+          <p:cNvSpPr/>
+          <p:nvPr/>
+        </p:nvSpPr>
+        <p:spPr>
+          <a:xfrm>
+            <a:off x="868680" y="2194560"/>
+            <a:ext cx="4937760" cy="3108960"/>
           </a:xfrm>
           <a:prstGeom prst="rect">
             <a:avLst/>
@@ -5961,7 +5953,7 @@
           <a:p>
             <a:pPr marL="177800" indent="-177800">
               <a:spcAft>
-                <a:spcPts val="900"/>
+                <a:spcPts val="800"/>
               </a:spcAft>
               <a:buSzPct val="100000"/>
               <a:buChar char="•"/>
@@ -5975,14 +5967,14 @@
                 <a:ea typeface="맑은 고딕" pitchFamily="34" charset="-122"/>
                 <a:cs typeface="맑은 고딕" pitchFamily="34" charset="-120"/>
               </a:rPr>
-              <a:t>사소한 표현까지 잡는 경향</a:t>
+              <a:t>컴포넌트 기반 → 화면 재사용·유지보수 쉬움</a:t>
             </a:r>
             <a:endParaRPr lang="en-US" sz="1500" dirty="0"/>
           </a:p>
           <a:p>
             <a:pPr marL="177800" indent="-177800">
               <a:spcAft>
-                <a:spcPts val="900"/>
+                <a:spcPts val="800"/>
               </a:spcAft>
               <a:buSzPct val="100000"/>
               <a:buChar char="•"/>
@@ -5996,30 +5988,51 @@
                 <a:ea typeface="맑은 고딕" pitchFamily="34" charset="-122"/>
                 <a:cs typeface="맑은 고딕" pitchFamily="34" charset="-120"/>
               </a:rPr>
-              <a:t>→ 도메인 지식·기준 프롬프트 정교화로 완화</a:t>
+              <a:t>상태관리로 검출·해결 상태 즉시 반영 (인터랙티브)</a:t>
             </a:r>
             <a:endParaRPr lang="en-US" sz="1500" dirty="0"/>
           </a:p>
-        </p:txBody>
-      </p:sp>
-      <p:sp>
-        <p:nvSpPr>
-          <p:cNvPr id="11" name="Shape 9"/>
-          <p:cNvSpPr/>
-          <p:nvPr/>
-        </p:nvSpPr>
-        <p:spPr>
-          <a:xfrm>
-            <a:off x="6199632" y="3474720"/>
-            <a:ext cx="5440680" cy="2103120"/>
+          <a:p>
+            <a:pPr marL="177800" indent="-177800">
+              <a:spcAft>
+                <a:spcPts val="800"/>
+              </a:spcAft>
+              <a:buSzPct val="100000"/>
+              <a:buChar char="•"/>
+            </a:pPr>
+            <a:r>
+              <a:rPr lang="en-US" sz="1500" dirty="0">
+                <a:solidFill>
+                  <a:srgbClr val="1F2733"/>
+                </a:solidFill>
+                <a:latin typeface="맑은 고딕" pitchFamily="34" charset="0"/>
+                <a:ea typeface="맑은 고딕" pitchFamily="34" charset="-122"/>
+                <a:cs typeface="맑은 고딕" pitchFamily="34" charset="-120"/>
+              </a:rPr>
+              <a:t>표준·생태계 넓음, 설계서 기술스택과 일치</a:t>
+            </a:r>
+            <a:endParaRPr lang="en-US" sz="1500" dirty="0"/>
+          </a:p>
+        </p:txBody>
+      </p:sp>
+      <p:sp>
+        <p:nvSpPr>
+          <p:cNvPr id="8" name="Shape 6"/>
+          <p:cNvSpPr/>
+          <p:nvPr/>
+        </p:nvSpPr>
+        <p:spPr>
+          <a:xfrm>
+            <a:off x="6309360" y="1463040"/>
+            <a:ext cx="5330952" cy="4114800"/>
           </a:xfrm>
           <a:prstGeom prst="roundRect">
             <a:avLst>
-              <a:gd name="adj" fmla="val 3478"/>
+              <a:gd name="adj" fmla="val 1778"/>
             </a:avLst>
           </a:prstGeom>
           <a:solidFill>
-            <a:srgbClr val="FFFFFF"/>
+            <a:srgbClr val="FDF4E7"/>
           </a:solidFill>
           <a:ln w="12700">
             <a:solidFill>
@@ -6038,14 +6051,14 @@
       </p:sp>
       <p:sp>
         <p:nvSpPr>
-          <p:cNvPr id="12" name="Text 10"/>
-          <p:cNvSpPr/>
-          <p:nvPr/>
-        </p:nvSpPr>
-        <p:spPr>
-          <a:xfrm>
-            <a:off x="6446520" y="3657600"/>
-            <a:ext cx="4937760" cy="457200"/>
+          <p:cNvPr id="9" name="Text 7"/>
+          <p:cNvSpPr/>
+          <p:nvPr/>
+        </p:nvSpPr>
+        <p:spPr>
+          <a:xfrm>
+            <a:off x="6583680" y="1645920"/>
+            <a:ext cx="4846320" cy="457200"/>
           </a:xfrm>
           <a:prstGeom prst="rect">
             <a:avLst/>
@@ -6061,30 +6074,30 @@
               <a:buNone/>
             </a:pPr>
             <a:r>
-              <a:rPr lang="en-US" sz="1700" b="1" dirty="0">
-                <a:solidFill>
-                  <a:srgbClr val="24395F"/>
-                </a:solidFill>
-                <a:latin typeface="맑은 고딕" pitchFamily="34" charset="0"/>
-                <a:ea typeface="맑은 고딕" pitchFamily="34" charset="-122"/>
-                <a:cs typeface="맑은 고딕" pitchFamily="34" charset="-120"/>
-              </a:rPr>
-              <a:t>다음 단계</a:t>
-            </a:r>
-            <a:endParaRPr lang="en-US" sz="1700" dirty="0"/>
-          </a:p>
-        </p:txBody>
-      </p:sp>
-      <p:sp>
-        <p:nvSpPr>
-          <p:cNvPr id="13" name="Text 11"/>
-          <p:cNvSpPr/>
-          <p:nvPr/>
-        </p:nvSpPr>
-        <p:spPr>
-          <a:xfrm>
-            <a:off x="6492240" y="4160520"/>
-            <a:ext cx="4846320" cy="1280160"/>
+              <a:rPr lang="en-US" sz="1900" b="1" dirty="0">
+                <a:solidFill>
+                  <a:srgbClr val="C67F17"/>
+                </a:solidFill>
+                <a:latin typeface="맑은 고딕" pitchFamily="34" charset="0"/>
+                <a:ea typeface="맑은 고딕" pitchFamily="34" charset="-122"/>
+                <a:cs typeface="맑은 고딕" pitchFamily="34" charset="-120"/>
+              </a:rPr>
+              <a:t>이슈 (고민)</a:t>
+            </a:r>
+            <a:endParaRPr lang="en-US" sz="1900" dirty="0"/>
+          </a:p>
+        </p:txBody>
+      </p:sp>
+      <p:sp>
+        <p:nvSpPr>
+          <p:cNvPr id="10" name="Text 8"/>
+          <p:cNvSpPr/>
+          <p:nvPr/>
+        </p:nvSpPr>
+        <p:spPr>
+          <a:xfrm>
+            <a:off x="6583680" y="2194560"/>
+            <a:ext cx="4754880" cy="3108960"/>
           </a:xfrm>
           <a:prstGeom prst="rect">
             <a:avLst/>
@@ -6098,13 +6111,13 @@
           <a:p>
             <a:pPr marL="177800" indent="-177800">
               <a:spcAft>
-                <a:spcPts val="900"/>
+                <a:spcPts val="800"/>
               </a:spcAft>
               <a:buSzPct val="100000"/>
               <a:buChar char="•"/>
             </a:pPr>
             <a:r>
-              <a:rPr lang="en-US" sz="1500" dirty="0">
+              <a:rPr lang="en-US" sz="1500" b="1" dirty="0">
                 <a:solidFill>
                   <a:srgbClr val="1F2733"/>
                 </a:solidFill>
@@ -6112,19 +6125,40 @@
                 <a:ea typeface="맑은 고딕" pitchFamily="34" charset="-122"/>
                 <a:cs typeface="맑은 고딕" pitchFamily="34" charset="-120"/>
               </a:rPr>
-              <a:t>docx(→hwp) 입력 문제 해결 우선</a:t>
+              <a:t>빌드에 필요한 npm install이 사내 프록시 인증서로 막힘</a:t>
             </a:r>
             <a:endParaRPr lang="en-US" sz="1500" dirty="0"/>
           </a:p>
           <a:p>
             <a:pPr marL="177800" indent="-177800">
               <a:spcAft>
-                <a:spcPts val="900"/>
+                <a:spcPts val="800"/>
               </a:spcAft>
               <a:buSzPct val="100000"/>
               <a:buChar char="•"/>
             </a:pPr>
             <a:r>
+              <a:rPr lang="en-US" sz="1300" dirty="0">
+                <a:solidFill>
+                  <a:srgbClr val="63707E"/>
+                </a:solidFill>
+                <a:latin typeface="맑은 고딕" pitchFamily="34" charset="0"/>
+                <a:ea typeface="맑은 고딕" pitchFamily="34" charset="-122"/>
+                <a:cs typeface="맑은 고딕" pitchFamily="34" charset="-120"/>
+              </a:rPr>
+              <a:t>( UNABLE_TO_VERIFY_LEAF_SIGNATURE )</a:t>
+            </a:r>
+            <a:endParaRPr lang="en-US" sz="1500" dirty="0"/>
+          </a:p>
+          <a:p>
+            <a:pPr marL="177800" indent="-177800">
+              <a:spcAft>
+                <a:spcPts val="1200"/>
+              </a:spcAft>
+              <a:buSzPct val="100000"/>
+              <a:buChar char="•"/>
+            </a:pPr>
+            <a:r>
               <a:rPr lang="en-US" sz="1500" dirty="0">
                 <a:solidFill>
                   <a:srgbClr val="1F2733"/>
@@ -6133,7 +6167,28 @@
                 <a:ea typeface="맑은 고딕" pitchFamily="34" charset="-122"/>
                 <a:cs typeface="맑은 고딕" pitchFamily="34" charset="-120"/>
               </a:rPr>
-              <a:t>데이터모델·백엔드 확장, 기능 도출부 구현</a:t>
+              <a:t>보안이라 함부로 설정 변경도 어려움</a:t>
+            </a:r>
+            <a:endParaRPr lang="en-US" sz="1500" dirty="0"/>
+          </a:p>
+          <a:p>
+            <a:pPr marL="177800" indent="-177800">
+              <a:spcAft>
+                <a:spcPts val="800"/>
+              </a:spcAft>
+              <a:buSzPct val="100000"/>
+              <a:buChar char="•"/>
+            </a:pPr>
+            <a:r>
+              <a:rPr lang="en-US" sz="1500" dirty="0">
+                <a:solidFill>
+                  <a:srgbClr val="2A8A57"/>
+                </a:solidFill>
+                <a:latin typeface="맑은 고딕" pitchFamily="34" charset="0"/>
+                <a:ea typeface="맑은 고딕" pitchFamily="34" charset="-122"/>
+                <a:cs typeface="맑은 고딕" pitchFamily="34" charset="-120"/>
+              </a:rPr>
+              <a:t>임시 대응: 미리 빌드한 결과물(dist)만 넣어 실행 → npm 없이 구동</a:t>
             </a:r>
             <a:endParaRPr lang="en-US" sz="1500" dirty="0"/>
           </a:p>

</xml_diff>

<commit_message>
추적성 이미지: Jira 티켓 3개 전개 + 실제 ID 연결(AMVCS30-77~85, AMSWV-2163~65)
- 연결관리: req-ta-01 ↔ 티켓3개(상위 개발중/대기) 각 SWVOC/Function Requirement/Detail Design
- 변경추적: 실제 티켓 ID 기준 영향받음/영향없음 구분
- PPT 슬라이드7 레이아웃 재조정(세로 확장 대응)

Co-Authored-By: Claude Opus 4.8 <noreply@anthropic.com>
Claude-Session: https://claude.ai/code/session_01XZsaNq51dTbGYngjvrKZNK
</commit_message>
<xml_diff>
--- a/docs/진행공유_요구사항자동화.pptx
+++ b/docs/진행공유_요구사항자동화.pptx
@@ -2906,7 +2906,7 @@
         </p:nvSpPr>
         <p:spPr>
           <a:xfrm>
-            <a:off x="566928" y="1572768"/>
+            <a:off x="566928" y="1463040"/>
             <a:ext cx="11064240" cy="320040"/>
           </a:xfrm>
           <a:prstGeom prst="rect">
@@ -2967,8 +2967,8 @@
         </p:blipFill>
         <p:spPr>
           <a:xfrm>
-            <a:off x="699516" y="1938528"/>
-            <a:ext cx="10789920" cy="2211934"/>
+            <a:off x="1065276" y="1783080"/>
+            <a:ext cx="10058400" cy="2628900"/>
           </a:xfrm>
           <a:prstGeom prst="rect">
             <a:avLst/>
@@ -2983,7 +2983,7 @@
         </p:nvSpPr>
         <p:spPr>
           <a:xfrm>
-            <a:off x="566928" y="4224528"/>
+            <a:off x="566928" y="4480560"/>
             <a:ext cx="11064240" cy="320040"/>
           </a:xfrm>
           <a:prstGeom prst="rect">
@@ -3044,8 +3044,8 @@
         </p:blipFill>
         <p:spPr>
           <a:xfrm>
-            <a:off x="699516" y="4590288"/>
-            <a:ext cx="10789920" cy="1672438"/>
+            <a:off x="1065276" y="4800600"/>
+            <a:ext cx="10058400" cy="1559052"/>
           </a:xfrm>
           <a:prstGeom prst="rect">
             <a:avLst/>

</xml_diff>